<commit_message>
Fix presentation bullet spacing
Co-authored-by: Copilot <223556219+Copilot@users.noreply.github.com>
</commit_message>
<xml_diff>
--- a/docs/csv-user-manager-presentation.pptx
+++ b/docs/csv-user-manager-presentation.pptx
@@ -3311,7 +3311,7 @@
         <p:spPr>
           <a:xfrm>
             <a:off x="822960" y="1371600"/>
-            <a:ext cx="10332720" cy="347472"/>
+            <a:ext cx="10332720" cy="566928"/>
           </a:xfrm>
           <a:prstGeom prst="rect">
             <a:avLst/>
@@ -3346,8 +3346,8 @@
         </p:nvSpPr>
         <p:spPr>
           <a:xfrm>
-            <a:off x="822960" y="1810512"/>
-            <a:ext cx="10332720" cy="347472"/>
+            <a:off x="822960" y="2057400"/>
+            <a:ext cx="10332720" cy="566928"/>
           </a:xfrm>
           <a:prstGeom prst="rect">
             <a:avLst/>
@@ -3382,8 +3382,8 @@
         </p:nvSpPr>
         <p:spPr>
           <a:xfrm>
-            <a:off x="822960" y="2249424"/>
-            <a:ext cx="10332720" cy="347472"/>
+            <a:off x="822960" y="2743200"/>
+            <a:ext cx="10332720" cy="566928"/>
           </a:xfrm>
           <a:prstGeom prst="rect">
             <a:avLst/>
@@ -3418,8 +3418,8 @@
         </p:nvSpPr>
         <p:spPr>
           <a:xfrm>
-            <a:off x="822960" y="2688336"/>
-            <a:ext cx="10332720" cy="347472"/>
+            <a:off x="822960" y="3429000"/>
+            <a:ext cx="10332720" cy="566928"/>
           </a:xfrm>
           <a:prstGeom prst="rect">
             <a:avLst/>
@@ -3454,8 +3454,8 @@
         </p:nvSpPr>
         <p:spPr>
           <a:xfrm>
-            <a:off x="822960" y="3127248"/>
-            <a:ext cx="10332720" cy="347472"/>
+            <a:off x="822960" y="4114800"/>
+            <a:ext cx="10332720" cy="566928"/>
           </a:xfrm>
           <a:prstGeom prst="rect">
             <a:avLst/>
@@ -6581,7 +6581,7 @@
         <p:spPr>
           <a:xfrm>
             <a:off x="822960" y="1371600"/>
-            <a:ext cx="10332720" cy="347472"/>
+            <a:ext cx="10332720" cy="566928"/>
           </a:xfrm>
           <a:prstGeom prst="rect">
             <a:avLst/>
@@ -6616,8 +6616,8 @@
         </p:nvSpPr>
         <p:spPr>
           <a:xfrm>
-            <a:off x="822960" y="1810512"/>
-            <a:ext cx="10332720" cy="347472"/>
+            <a:off x="822960" y="2057400"/>
+            <a:ext cx="10332720" cy="566928"/>
           </a:xfrm>
           <a:prstGeom prst="rect">
             <a:avLst/>
@@ -6652,8 +6652,8 @@
         </p:nvSpPr>
         <p:spPr>
           <a:xfrm>
-            <a:off x="822960" y="2249424"/>
-            <a:ext cx="10332720" cy="347472"/>
+            <a:off x="822960" y="2743200"/>
+            <a:ext cx="10332720" cy="566928"/>
           </a:xfrm>
           <a:prstGeom prst="rect">
             <a:avLst/>
@@ -6688,8 +6688,8 @@
         </p:nvSpPr>
         <p:spPr>
           <a:xfrm>
-            <a:off x="822960" y="2688336"/>
-            <a:ext cx="10332720" cy="347472"/>
+            <a:off x="822960" y="3429000"/>
+            <a:ext cx="10332720" cy="566928"/>
           </a:xfrm>
           <a:prstGeom prst="rect">
             <a:avLst/>
@@ -6724,8 +6724,8 @@
         </p:nvSpPr>
         <p:spPr>
           <a:xfrm>
-            <a:off x="822960" y="3127248"/>
-            <a:ext cx="10332720" cy="347472"/>
+            <a:off x="822960" y="4114800"/>
+            <a:ext cx="10332720" cy="566928"/>
           </a:xfrm>
           <a:prstGeom prst="rect">
             <a:avLst/>
@@ -6760,8 +6760,8 @@
         </p:nvSpPr>
         <p:spPr>
           <a:xfrm>
-            <a:off x="822960" y="3566160"/>
-            <a:ext cx="10332720" cy="347472"/>
+            <a:off x="822960" y="4800600"/>
+            <a:ext cx="10332720" cy="566928"/>
           </a:xfrm>
           <a:prstGeom prst="rect">
             <a:avLst/>

</xml_diff>

<commit_message>
Align presentation feature cards
Co-authored-by: Copilot <223556219+Copilot@users.noreply.github.com>
</commit_message>
<xml_diff>
--- a/docs/csv-user-manager-presentation.pptx
+++ b/docs/csv-user-manager-presentation.pptx
@@ -3121,7 +3121,7 @@
           <a:noFill/>
         </p:spPr>
         <p:txBody>
-          <a:bodyPr wrap="square">
+          <a:bodyPr wrap="square" lIns="0" rIns="0" tIns="0" bIns="0">
             <a:spAutoFit/>
           </a:bodyPr>
           <a:lstStyle/>
@@ -3157,7 +3157,7 @@
           <a:noFill/>
         </p:spPr>
         <p:txBody>
-          <a:bodyPr wrap="square">
+          <a:bodyPr wrap="square" lIns="0" rIns="0" tIns="0" bIns="0">
             <a:spAutoFit/>
           </a:bodyPr>
           <a:lstStyle/>
@@ -3193,7 +3193,7 @@
           <a:noFill/>
         </p:spPr>
         <p:txBody>
-          <a:bodyPr wrap="square">
+          <a:bodyPr wrap="square" lIns="0" rIns="0" tIns="0" bIns="0">
             <a:spAutoFit/>
           </a:bodyPr>
           <a:lstStyle/>
@@ -3247,7 +3247,7 @@
           <a:noFill/>
         </p:spPr>
         <p:txBody>
-          <a:bodyPr wrap="square">
+          <a:bodyPr wrap="square" lIns="0" rIns="0" tIns="0" bIns="0">
             <a:spAutoFit/>
           </a:bodyPr>
           <a:lstStyle/>
@@ -3283,7 +3283,7 @@
           <a:noFill/>
         </p:spPr>
         <p:txBody>
-          <a:bodyPr wrap="square">
+          <a:bodyPr wrap="square" lIns="0" rIns="0" tIns="0" bIns="0">
             <a:spAutoFit/>
           </a:bodyPr>
           <a:lstStyle/>
@@ -3319,7 +3319,7 @@
           <a:noFill/>
         </p:spPr>
         <p:txBody>
-          <a:bodyPr wrap="square">
+          <a:bodyPr wrap="square" lIns="0" rIns="0" tIns="0" bIns="0">
             <a:spAutoFit/>
           </a:bodyPr>
           <a:lstStyle/>
@@ -3355,7 +3355,7 @@
           <a:noFill/>
         </p:spPr>
         <p:txBody>
-          <a:bodyPr wrap="square">
+          <a:bodyPr wrap="square" lIns="0" rIns="0" tIns="0" bIns="0">
             <a:spAutoFit/>
           </a:bodyPr>
           <a:lstStyle/>
@@ -3391,7 +3391,7 @@
           <a:noFill/>
         </p:spPr>
         <p:txBody>
-          <a:bodyPr wrap="square">
+          <a:bodyPr wrap="square" lIns="0" rIns="0" tIns="0" bIns="0">
             <a:spAutoFit/>
           </a:bodyPr>
           <a:lstStyle/>
@@ -3427,7 +3427,7 @@
           <a:noFill/>
         </p:spPr>
         <p:txBody>
-          <a:bodyPr wrap="square">
+          <a:bodyPr wrap="square" lIns="0" rIns="0" tIns="0" bIns="0">
             <a:spAutoFit/>
           </a:bodyPr>
           <a:lstStyle/>
@@ -3463,7 +3463,7 @@
           <a:noFill/>
         </p:spPr>
         <p:txBody>
-          <a:bodyPr wrap="square">
+          <a:bodyPr wrap="square" lIns="0" rIns="0" tIns="0" bIns="0">
             <a:spAutoFit/>
           </a:bodyPr>
           <a:lstStyle/>
@@ -3517,7 +3517,7 @@
           <a:noFill/>
         </p:spPr>
         <p:txBody>
-          <a:bodyPr wrap="square">
+          <a:bodyPr wrap="square" lIns="0" rIns="0" tIns="0" bIns="0">
             <a:spAutoFit/>
           </a:bodyPr>
           <a:lstStyle/>
@@ -3553,7 +3553,7 @@
           <a:noFill/>
         </p:spPr>
         <p:txBody>
-          <a:bodyPr wrap="square">
+          <a:bodyPr wrap="square" lIns="0" rIns="0" tIns="0" bIns="0">
             <a:spAutoFit/>
           </a:bodyPr>
           <a:lstStyle/>
@@ -3631,7 +3631,7 @@
           <a:noFill/>
         </p:spPr>
         <p:txBody>
-          <a:bodyPr wrap="square">
+          <a:bodyPr wrap="square" lIns="0" rIns="0" tIns="0" bIns="0">
             <a:spAutoFit/>
           </a:bodyPr>
           <a:lstStyle/>
@@ -3659,7 +3659,7 @@
         <p:spPr>
           <a:xfrm>
             <a:off x="640080" y="1234440"/>
-            <a:ext cx="3474720" cy="1417320"/>
+            <a:ext cx="3474720" cy="1554480"/>
           </a:xfrm>
           <a:prstGeom prst="roundRect">
             <a:avLst/>
@@ -3712,7 +3712,7 @@
           <a:noFill/>
         </p:spPr>
         <p:txBody>
-          <a:bodyPr wrap="square">
+          <a:bodyPr wrap="square" lIns="0" rIns="0" tIns="0" bIns="0">
             <a:spAutoFit/>
           </a:bodyPr>
           <a:lstStyle/>
@@ -3740,21 +3740,21 @@
         <p:spPr>
           <a:xfrm>
             <a:off x="804671" y="1801368"/>
-            <a:ext cx="3154679" cy="731520"/>
-          </a:xfrm>
-          <a:prstGeom prst="rect">
-            <a:avLst/>
-          </a:prstGeom>
-          <a:noFill/>
-        </p:spPr>
-        <p:txBody>
-          <a:bodyPr wrap="square">
-            <a:spAutoFit/>
-          </a:bodyPr>
-          <a:lstStyle/>
-          <a:p>
-            <a:pPr>
-              <a:defRPr sz="1400" b="0">
+            <a:ext cx="3154679" cy="868680"/>
+          </a:xfrm>
+          <a:prstGeom prst="rect">
+            <a:avLst/>
+          </a:prstGeom>
+          <a:noFill/>
+        </p:spPr>
+        <p:txBody>
+          <a:bodyPr wrap="square" lIns="0" rIns="0" tIns="0" bIns="0">
+            <a:spAutoFit/>
+          </a:bodyPr>
+          <a:lstStyle/>
+          <a:p>
+            <a:pPr>
+              <a:defRPr sz="1300" b="0">
                 <a:solidFill>
                   <a:srgbClr val="414141"/>
                 </a:solidFill>
@@ -3776,7 +3776,7 @@
         <p:spPr>
           <a:xfrm>
             <a:off x="4389120" y="1234440"/>
-            <a:ext cx="3474720" cy="1417320"/>
+            <a:ext cx="3474720" cy="1554480"/>
           </a:xfrm>
           <a:prstGeom prst="roundRect">
             <a:avLst/>
@@ -3829,7 +3829,7 @@
           <a:noFill/>
         </p:spPr>
         <p:txBody>
-          <a:bodyPr wrap="square">
+          <a:bodyPr wrap="square" lIns="0" rIns="0" tIns="0" bIns="0">
             <a:spAutoFit/>
           </a:bodyPr>
           <a:lstStyle/>
@@ -3857,21 +3857,21 @@
         <p:spPr>
           <a:xfrm>
             <a:off x="4553712" y="1801368"/>
-            <a:ext cx="3154679" cy="731520"/>
-          </a:xfrm>
-          <a:prstGeom prst="rect">
-            <a:avLst/>
-          </a:prstGeom>
-          <a:noFill/>
-        </p:spPr>
-        <p:txBody>
-          <a:bodyPr wrap="square">
-            <a:spAutoFit/>
-          </a:bodyPr>
-          <a:lstStyle/>
-          <a:p>
-            <a:pPr>
-              <a:defRPr sz="1400" b="0">
+            <a:ext cx="3154679" cy="868680"/>
+          </a:xfrm>
+          <a:prstGeom prst="rect">
+            <a:avLst/>
+          </a:prstGeom>
+          <a:noFill/>
+        </p:spPr>
+        <p:txBody>
+          <a:bodyPr wrap="square" lIns="0" rIns="0" tIns="0" bIns="0">
+            <a:spAutoFit/>
+          </a:bodyPr>
+          <a:lstStyle/>
+          <a:p>
+            <a:pPr>
+              <a:defRPr sz="1300" b="0">
                 <a:solidFill>
                   <a:srgbClr val="414141"/>
                 </a:solidFill>
@@ -3893,7 +3893,7 @@
         <p:spPr>
           <a:xfrm>
             <a:off x="8138160" y="1234440"/>
-            <a:ext cx="3474720" cy="1417320"/>
+            <a:ext cx="3474720" cy="1554480"/>
           </a:xfrm>
           <a:prstGeom prst="roundRect">
             <a:avLst/>
@@ -3946,7 +3946,7 @@
           <a:noFill/>
         </p:spPr>
         <p:txBody>
-          <a:bodyPr wrap="square">
+          <a:bodyPr wrap="square" lIns="0" rIns="0" tIns="0" bIns="0">
             <a:spAutoFit/>
           </a:bodyPr>
           <a:lstStyle/>
@@ -3974,21 +3974,21 @@
         <p:spPr>
           <a:xfrm>
             <a:off x="8302752" y="1801368"/>
-            <a:ext cx="3154679" cy="731520"/>
-          </a:xfrm>
-          <a:prstGeom prst="rect">
-            <a:avLst/>
-          </a:prstGeom>
-          <a:noFill/>
-        </p:spPr>
-        <p:txBody>
-          <a:bodyPr wrap="square">
-            <a:spAutoFit/>
-          </a:bodyPr>
-          <a:lstStyle/>
-          <a:p>
-            <a:pPr>
-              <a:defRPr sz="1400" b="0">
+            <a:ext cx="3154679" cy="868680"/>
+          </a:xfrm>
+          <a:prstGeom prst="rect">
+            <a:avLst/>
+          </a:prstGeom>
+          <a:noFill/>
+        </p:spPr>
+        <p:txBody>
+          <a:bodyPr wrap="square" lIns="0" rIns="0" tIns="0" bIns="0">
+            <a:spAutoFit/>
+          </a:bodyPr>
+          <a:lstStyle/>
+          <a:p>
+            <a:pPr>
+              <a:defRPr sz="1300" b="0">
                 <a:solidFill>
                   <a:srgbClr val="414141"/>
                 </a:solidFill>
@@ -4009,8 +4009,8 @@
         </p:nvSpPr>
         <p:spPr>
           <a:xfrm>
-            <a:off x="640080" y="3063240"/>
-            <a:ext cx="3474720" cy="1417320"/>
+            <a:off x="640080" y="3154680"/>
+            <a:ext cx="3474720" cy="1554480"/>
           </a:xfrm>
           <a:prstGeom prst="roundRect">
             <a:avLst/>
@@ -4054,7 +4054,7 @@
         </p:nvSpPr>
         <p:spPr>
           <a:xfrm>
-            <a:off x="804671" y="3200400"/>
+            <a:off x="804671" y="3291840"/>
             <a:ext cx="3154679" cy="320040"/>
           </a:xfrm>
           <a:prstGeom prst="rect">
@@ -4063,7 +4063,7 @@
           <a:noFill/>
         </p:spPr>
         <p:txBody>
-          <a:bodyPr wrap="square">
+          <a:bodyPr wrap="square" lIns="0" rIns="0" tIns="0" bIns="0">
             <a:spAutoFit/>
           </a:bodyPr>
           <a:lstStyle/>
@@ -4090,22 +4090,22 @@
         </p:nvSpPr>
         <p:spPr>
           <a:xfrm>
-            <a:off x="804671" y="3630168"/>
-            <a:ext cx="3154679" cy="731520"/>
-          </a:xfrm>
-          <a:prstGeom prst="rect">
-            <a:avLst/>
-          </a:prstGeom>
-          <a:noFill/>
-        </p:spPr>
-        <p:txBody>
-          <a:bodyPr wrap="square">
-            <a:spAutoFit/>
-          </a:bodyPr>
-          <a:lstStyle/>
-          <a:p>
-            <a:pPr>
-              <a:defRPr sz="1400" b="0">
+            <a:off x="804671" y="3721608"/>
+            <a:ext cx="3154679" cy="868680"/>
+          </a:xfrm>
+          <a:prstGeom prst="rect">
+            <a:avLst/>
+          </a:prstGeom>
+          <a:noFill/>
+        </p:spPr>
+        <p:txBody>
+          <a:bodyPr wrap="square" lIns="0" rIns="0" tIns="0" bIns="0">
+            <a:spAutoFit/>
+          </a:bodyPr>
+          <a:lstStyle/>
+          <a:p>
+            <a:pPr>
+              <a:defRPr sz="1300" b="0">
                 <a:solidFill>
                   <a:srgbClr val="414141"/>
                 </a:solidFill>
@@ -4126,8 +4126,8 @@
         </p:nvSpPr>
         <p:spPr>
           <a:xfrm>
-            <a:off x="4389120" y="3063240"/>
-            <a:ext cx="3474720" cy="1417320"/>
+            <a:off x="4389120" y="3154680"/>
+            <a:ext cx="3474720" cy="1554480"/>
           </a:xfrm>
           <a:prstGeom prst="roundRect">
             <a:avLst/>
@@ -4171,7 +4171,7 @@
         </p:nvSpPr>
         <p:spPr>
           <a:xfrm>
-            <a:off x="4553712" y="3200400"/>
+            <a:off x="4553712" y="3291840"/>
             <a:ext cx="3154679" cy="320040"/>
           </a:xfrm>
           <a:prstGeom prst="rect">
@@ -4180,7 +4180,7 @@
           <a:noFill/>
         </p:spPr>
         <p:txBody>
-          <a:bodyPr wrap="square">
+          <a:bodyPr wrap="square" lIns="0" rIns="0" tIns="0" bIns="0">
             <a:spAutoFit/>
           </a:bodyPr>
           <a:lstStyle/>
@@ -4207,22 +4207,22 @@
         </p:nvSpPr>
         <p:spPr>
           <a:xfrm>
-            <a:off x="4553712" y="3630168"/>
-            <a:ext cx="3154679" cy="731520"/>
-          </a:xfrm>
-          <a:prstGeom prst="rect">
-            <a:avLst/>
-          </a:prstGeom>
-          <a:noFill/>
-        </p:spPr>
-        <p:txBody>
-          <a:bodyPr wrap="square">
-            <a:spAutoFit/>
-          </a:bodyPr>
-          <a:lstStyle/>
-          <a:p>
-            <a:pPr>
-              <a:defRPr sz="1400" b="0">
+            <a:off x="4553712" y="3721608"/>
+            <a:ext cx="3154679" cy="868680"/>
+          </a:xfrm>
+          <a:prstGeom prst="rect">
+            <a:avLst/>
+          </a:prstGeom>
+          <a:noFill/>
+        </p:spPr>
+        <p:txBody>
+          <a:bodyPr wrap="square" lIns="0" rIns="0" tIns="0" bIns="0">
+            <a:spAutoFit/>
+          </a:bodyPr>
+          <a:lstStyle/>
+          <a:p>
+            <a:pPr>
+              <a:defRPr sz="1300" b="0">
                 <a:solidFill>
                   <a:srgbClr val="414141"/>
                 </a:solidFill>
@@ -4243,8 +4243,8 @@
         </p:nvSpPr>
         <p:spPr>
           <a:xfrm>
-            <a:off x="8138160" y="3063240"/>
-            <a:ext cx="3474720" cy="1417320"/>
+            <a:off x="8138160" y="3154680"/>
+            <a:ext cx="3474720" cy="1554480"/>
           </a:xfrm>
           <a:prstGeom prst="roundRect">
             <a:avLst/>
@@ -4288,7 +4288,7 @@
         </p:nvSpPr>
         <p:spPr>
           <a:xfrm>
-            <a:off x="8302752" y="3200400"/>
+            <a:off x="8302752" y="3291840"/>
             <a:ext cx="3154679" cy="320040"/>
           </a:xfrm>
           <a:prstGeom prst="rect">
@@ -4297,7 +4297,7 @@
           <a:noFill/>
         </p:spPr>
         <p:txBody>
-          <a:bodyPr wrap="square">
+          <a:bodyPr wrap="square" lIns="0" rIns="0" tIns="0" bIns="0">
             <a:spAutoFit/>
           </a:bodyPr>
           <a:lstStyle/>
@@ -4324,22 +4324,22 @@
         </p:nvSpPr>
         <p:spPr>
           <a:xfrm>
-            <a:off x="8302752" y="3630168"/>
-            <a:ext cx="3154679" cy="731520"/>
-          </a:xfrm>
-          <a:prstGeom prst="rect">
-            <a:avLst/>
-          </a:prstGeom>
-          <a:noFill/>
-        </p:spPr>
-        <p:txBody>
-          <a:bodyPr wrap="square">
-            <a:spAutoFit/>
-          </a:bodyPr>
-          <a:lstStyle/>
-          <a:p>
-            <a:pPr>
-              <a:defRPr sz="1400" b="0">
+            <a:off x="8302752" y="3721608"/>
+            <a:ext cx="3154679" cy="868680"/>
+          </a:xfrm>
+          <a:prstGeom prst="rect">
+            <a:avLst/>
+          </a:prstGeom>
+          <a:noFill/>
+        </p:spPr>
+        <p:txBody>
+          <a:bodyPr wrap="square" lIns="0" rIns="0" tIns="0" bIns="0">
+            <a:spAutoFit/>
+          </a:bodyPr>
+          <a:lstStyle/>
+          <a:p>
+            <a:pPr>
+              <a:defRPr sz="1300" b="0">
                 <a:solidFill>
                   <a:srgbClr val="414141"/>
                 </a:solidFill>
@@ -4387,7 +4387,7 @@
           <a:noFill/>
         </p:spPr>
         <p:txBody>
-          <a:bodyPr wrap="square">
+          <a:bodyPr wrap="square" lIns="0" rIns="0" tIns="0" bIns="0">
             <a:spAutoFit/>
           </a:bodyPr>
           <a:lstStyle/>
@@ -4423,7 +4423,7 @@
           <a:noFill/>
         </p:spPr>
         <p:txBody>
-          <a:bodyPr wrap="square">
+          <a:bodyPr wrap="square" lIns="0" rIns="0" tIns="0" bIns="0">
             <a:spAutoFit/>
           </a:bodyPr>
           <a:lstStyle/>
@@ -4504,7 +4504,7 @@
           <a:noFill/>
         </p:spPr>
         <p:txBody>
-          <a:bodyPr wrap="square">
+          <a:bodyPr wrap="square" lIns="0" rIns="0" tIns="0" bIns="0">
             <a:spAutoFit/>
           </a:bodyPr>
           <a:lstStyle/>
@@ -4540,13 +4540,13 @@
           <a:noFill/>
         </p:spPr>
         <p:txBody>
-          <a:bodyPr wrap="square">
-            <a:spAutoFit/>
-          </a:bodyPr>
-          <a:lstStyle/>
-          <a:p>
-            <a:pPr>
-              <a:defRPr sz="1400" b="0">
+          <a:bodyPr wrap="square" lIns="0" rIns="0" tIns="0" bIns="0">
+            <a:spAutoFit/>
+          </a:bodyPr>
+          <a:lstStyle/>
+          <a:p>
+            <a:pPr>
+              <a:defRPr sz="1300" b="0">
                 <a:solidFill>
                   <a:srgbClr val="414141"/>
                 </a:solidFill>
@@ -4621,7 +4621,7 @@
           <a:noFill/>
         </p:spPr>
         <p:txBody>
-          <a:bodyPr wrap="square">
+          <a:bodyPr wrap="square" lIns="0" rIns="0" tIns="0" bIns="0">
             <a:spAutoFit/>
           </a:bodyPr>
           <a:lstStyle/>
@@ -4657,13 +4657,13 @@
           <a:noFill/>
         </p:spPr>
         <p:txBody>
-          <a:bodyPr wrap="square">
-            <a:spAutoFit/>
-          </a:bodyPr>
-          <a:lstStyle/>
-          <a:p>
-            <a:pPr>
-              <a:defRPr sz="1400" b="0">
+          <a:bodyPr wrap="square" lIns="0" rIns="0" tIns="0" bIns="0">
+            <a:spAutoFit/>
+          </a:bodyPr>
+          <a:lstStyle/>
+          <a:p>
+            <a:pPr>
+              <a:defRPr sz="1300" b="0">
                 <a:solidFill>
                   <a:srgbClr val="414141"/>
                 </a:solidFill>
@@ -4738,7 +4738,7 @@
           <a:noFill/>
         </p:spPr>
         <p:txBody>
-          <a:bodyPr wrap="square">
+          <a:bodyPr wrap="square" lIns="0" rIns="0" tIns="0" bIns="0">
             <a:spAutoFit/>
           </a:bodyPr>
           <a:lstStyle/>
@@ -4774,13 +4774,13 @@
           <a:noFill/>
         </p:spPr>
         <p:txBody>
-          <a:bodyPr wrap="square">
-            <a:spAutoFit/>
-          </a:bodyPr>
-          <a:lstStyle/>
-          <a:p>
-            <a:pPr>
-              <a:defRPr sz="1400" b="0">
+          <a:bodyPr wrap="square" lIns="0" rIns="0" tIns="0" bIns="0">
+            <a:spAutoFit/>
+          </a:bodyPr>
+          <a:lstStyle/>
+          <a:p>
+            <a:pPr>
+              <a:defRPr sz="1300" b="0">
                 <a:solidFill>
                   <a:srgbClr val="414141"/>
                 </a:solidFill>
@@ -4855,7 +4855,7 @@
           <a:noFill/>
         </p:spPr>
         <p:txBody>
-          <a:bodyPr wrap="square">
+          <a:bodyPr wrap="square" lIns="0" rIns="0" tIns="0" bIns="0">
             <a:spAutoFit/>
           </a:bodyPr>
           <a:lstStyle/>
@@ -4891,13 +4891,13 @@
           <a:noFill/>
         </p:spPr>
         <p:txBody>
-          <a:bodyPr wrap="square">
-            <a:spAutoFit/>
-          </a:bodyPr>
-          <a:lstStyle/>
-          <a:p>
-            <a:pPr>
-              <a:defRPr sz="1400" b="0">
+          <a:bodyPr wrap="square" lIns="0" rIns="0" tIns="0" bIns="0">
+            <a:spAutoFit/>
+          </a:bodyPr>
+          <a:lstStyle/>
+          <a:p>
+            <a:pPr>
+              <a:defRPr sz="1300" b="0">
                 <a:solidFill>
                   <a:srgbClr val="414141"/>
                 </a:solidFill>
@@ -4972,7 +4972,7 @@
           <a:noFill/>
         </p:spPr>
         <p:txBody>
-          <a:bodyPr wrap="square">
+          <a:bodyPr wrap="square" lIns="0" rIns="0" tIns="0" bIns="0">
             <a:spAutoFit/>
           </a:bodyPr>
           <a:lstStyle/>
@@ -5008,13 +5008,13 @@
           <a:noFill/>
         </p:spPr>
         <p:txBody>
-          <a:bodyPr wrap="square">
-            <a:spAutoFit/>
-          </a:bodyPr>
-          <a:lstStyle/>
-          <a:p>
-            <a:pPr>
-              <a:defRPr sz="1400" b="0">
+          <a:bodyPr wrap="square" lIns="0" rIns="0" tIns="0" bIns="0">
+            <a:spAutoFit/>
+          </a:bodyPr>
+          <a:lstStyle/>
+          <a:p>
+            <a:pPr>
+              <a:defRPr sz="1300" b="0">
                 <a:solidFill>
                   <a:srgbClr val="414141"/>
                 </a:solidFill>
@@ -5062,7 +5062,7 @@
           <a:noFill/>
         </p:spPr>
         <p:txBody>
-          <a:bodyPr wrap="square">
+          <a:bodyPr wrap="square" lIns="0" rIns="0" tIns="0" bIns="0">
             <a:spAutoFit/>
           </a:bodyPr>
           <a:lstStyle/>
@@ -5098,7 +5098,7 @@
           <a:noFill/>
         </p:spPr>
         <p:txBody>
-          <a:bodyPr wrap="square">
+          <a:bodyPr wrap="square" lIns="0" rIns="0" tIns="0" bIns="0">
             <a:spAutoFit/>
           </a:bodyPr>
           <a:lstStyle/>
@@ -5179,7 +5179,7 @@
           <a:noFill/>
         </p:spPr>
         <p:txBody>
-          <a:bodyPr wrap="square">
+          <a:bodyPr wrap="square" lIns="0" rIns="0" tIns="0" bIns="0">
             <a:spAutoFit/>
           </a:bodyPr>
           <a:lstStyle/>
@@ -5215,7 +5215,7 @@
           <a:noFill/>
         </p:spPr>
         <p:txBody>
-          <a:bodyPr wrap="square">
+          <a:bodyPr wrap="square" lIns="0" rIns="0" tIns="0" bIns="0">
             <a:spAutoFit/>
           </a:bodyPr>
           <a:lstStyle/>
@@ -5251,7 +5251,7 @@
           <a:noFill/>
         </p:spPr>
         <p:txBody>
-          <a:bodyPr wrap="square">
+          <a:bodyPr wrap="square" lIns="0" rIns="0" tIns="0" bIns="0">
             <a:spAutoFit/>
           </a:bodyPr>
           <a:lstStyle/>
@@ -5287,7 +5287,7 @@
           <a:noFill/>
         </p:spPr>
         <p:txBody>
-          <a:bodyPr wrap="square">
+          <a:bodyPr wrap="square" lIns="0" rIns="0" tIns="0" bIns="0">
             <a:spAutoFit/>
           </a:bodyPr>
           <a:lstStyle/>
@@ -5368,7 +5368,7 @@
           <a:noFill/>
         </p:spPr>
         <p:txBody>
-          <a:bodyPr wrap="square">
+          <a:bodyPr wrap="square" lIns="0" rIns="0" tIns="0" bIns="0">
             <a:spAutoFit/>
           </a:bodyPr>
           <a:lstStyle/>
@@ -5404,7 +5404,7 @@
           <a:noFill/>
         </p:spPr>
         <p:txBody>
-          <a:bodyPr wrap="square">
+          <a:bodyPr wrap="square" lIns="0" rIns="0" tIns="0" bIns="0">
             <a:spAutoFit/>
           </a:bodyPr>
           <a:lstStyle/>
@@ -5440,7 +5440,7 @@
           <a:noFill/>
         </p:spPr>
         <p:txBody>
-          <a:bodyPr wrap="square">
+          <a:bodyPr wrap="square" lIns="0" rIns="0" tIns="0" bIns="0">
             <a:spAutoFit/>
           </a:bodyPr>
           <a:lstStyle/>
@@ -5476,7 +5476,7 @@
           <a:noFill/>
         </p:spPr>
         <p:txBody>
-          <a:bodyPr wrap="square">
+          <a:bodyPr wrap="square" lIns="0" rIns="0" tIns="0" bIns="0">
             <a:spAutoFit/>
           </a:bodyPr>
           <a:lstStyle/>
@@ -5557,7 +5557,7 @@
           <a:noFill/>
         </p:spPr>
         <p:txBody>
-          <a:bodyPr wrap="square">
+          <a:bodyPr wrap="square" lIns="0" rIns="0" tIns="0" bIns="0">
             <a:spAutoFit/>
           </a:bodyPr>
           <a:lstStyle/>
@@ -5593,7 +5593,7 @@
           <a:noFill/>
         </p:spPr>
         <p:txBody>
-          <a:bodyPr wrap="square">
+          <a:bodyPr wrap="square" lIns="0" rIns="0" tIns="0" bIns="0">
             <a:spAutoFit/>
           </a:bodyPr>
           <a:lstStyle/>
@@ -5629,7 +5629,7 @@
           <a:noFill/>
         </p:spPr>
         <p:txBody>
-          <a:bodyPr wrap="square">
+          <a:bodyPr wrap="square" lIns="0" rIns="0" tIns="0" bIns="0">
             <a:spAutoFit/>
           </a:bodyPr>
           <a:lstStyle/>
@@ -5665,7 +5665,7 @@
           <a:noFill/>
         </p:spPr>
         <p:txBody>
-          <a:bodyPr wrap="square">
+          <a:bodyPr wrap="square" lIns="0" rIns="0" tIns="0" bIns="0">
             <a:spAutoFit/>
           </a:bodyPr>
           <a:lstStyle/>
@@ -5746,7 +5746,7 @@
           <a:noFill/>
         </p:spPr>
         <p:txBody>
-          <a:bodyPr wrap="square">
+          <a:bodyPr wrap="square" lIns="0" rIns="0" tIns="0" bIns="0">
             <a:spAutoFit/>
           </a:bodyPr>
           <a:lstStyle/>
@@ -5782,7 +5782,7 @@
           <a:noFill/>
         </p:spPr>
         <p:txBody>
-          <a:bodyPr wrap="square">
+          <a:bodyPr wrap="square" lIns="0" rIns="0" tIns="0" bIns="0">
             <a:spAutoFit/>
           </a:bodyPr>
           <a:lstStyle/>
@@ -5818,7 +5818,7 @@
           <a:noFill/>
         </p:spPr>
         <p:txBody>
-          <a:bodyPr wrap="square">
+          <a:bodyPr wrap="square" lIns="0" rIns="0" tIns="0" bIns="0">
             <a:spAutoFit/>
           </a:bodyPr>
           <a:lstStyle/>
@@ -5854,7 +5854,7 @@
           <a:noFill/>
         </p:spPr>
         <p:txBody>
-          <a:bodyPr wrap="square">
+          <a:bodyPr wrap="square" lIns="0" rIns="0" tIns="0" bIns="0">
             <a:spAutoFit/>
           </a:bodyPr>
           <a:lstStyle/>
@@ -5935,7 +5935,7 @@
           <a:noFill/>
         </p:spPr>
         <p:txBody>
-          <a:bodyPr wrap="square">
+          <a:bodyPr wrap="square" lIns="0" rIns="0" tIns="0" bIns="0">
             <a:spAutoFit/>
           </a:bodyPr>
           <a:lstStyle/>
@@ -5971,7 +5971,7 @@
           <a:noFill/>
         </p:spPr>
         <p:txBody>
-          <a:bodyPr wrap="square">
+          <a:bodyPr wrap="square" lIns="0" rIns="0" tIns="0" bIns="0">
             <a:spAutoFit/>
           </a:bodyPr>
           <a:lstStyle/>
@@ -6007,7 +6007,7 @@
           <a:noFill/>
         </p:spPr>
         <p:txBody>
-          <a:bodyPr wrap="square">
+          <a:bodyPr wrap="square" lIns="0" rIns="0" tIns="0" bIns="0">
             <a:spAutoFit/>
           </a:bodyPr>
           <a:lstStyle/>
@@ -6061,7 +6061,7 @@
           <a:noFill/>
         </p:spPr>
         <p:txBody>
-          <a:bodyPr wrap="square">
+          <a:bodyPr wrap="square" lIns="0" rIns="0" tIns="0" bIns="0">
             <a:spAutoFit/>
           </a:bodyPr>
           <a:lstStyle/>
@@ -6097,7 +6097,7 @@
           <a:noFill/>
         </p:spPr>
         <p:txBody>
-          <a:bodyPr wrap="square">
+          <a:bodyPr wrap="square" lIns="0" rIns="0" tIns="0" bIns="0">
             <a:spAutoFit/>
           </a:bodyPr>
           <a:lstStyle/>
@@ -6178,7 +6178,7 @@
           <a:noFill/>
         </p:spPr>
         <p:txBody>
-          <a:bodyPr wrap="square">
+          <a:bodyPr wrap="square" lIns="0" rIns="0" tIns="0" bIns="0">
             <a:spAutoFit/>
           </a:bodyPr>
           <a:lstStyle/>
@@ -6214,13 +6214,13 @@
           <a:noFill/>
         </p:spPr>
         <p:txBody>
-          <a:bodyPr wrap="square">
-            <a:spAutoFit/>
-          </a:bodyPr>
-          <a:lstStyle/>
-          <a:p>
-            <a:pPr>
-              <a:defRPr sz="1400" b="0">
+          <a:bodyPr wrap="square" lIns="0" rIns="0" tIns="0" bIns="0">
+            <a:spAutoFit/>
+          </a:bodyPr>
+          <a:lstStyle/>
+          <a:p>
+            <a:pPr>
+              <a:defRPr sz="1300" b="0">
                 <a:solidFill>
                   <a:srgbClr val="414141"/>
                 </a:solidFill>
@@ -6300,7 +6300,7 @@
           <a:noFill/>
         </p:spPr>
         <p:txBody>
-          <a:bodyPr wrap="square">
+          <a:bodyPr wrap="square" lIns="0" rIns="0" tIns="0" bIns="0">
             <a:spAutoFit/>
           </a:bodyPr>
           <a:lstStyle/>
@@ -6336,13 +6336,13 @@
           <a:noFill/>
         </p:spPr>
         <p:txBody>
-          <a:bodyPr wrap="square">
-            <a:spAutoFit/>
-          </a:bodyPr>
-          <a:lstStyle/>
-          <a:p>
-            <a:pPr>
-              <a:defRPr sz="1400" b="0">
+          <a:bodyPr wrap="square" lIns="0" rIns="0" tIns="0" bIns="0">
+            <a:spAutoFit/>
+          </a:bodyPr>
+          <a:lstStyle/>
+          <a:p>
+            <a:pPr>
+              <a:defRPr sz="1300" b="0">
                 <a:solidFill>
                   <a:srgbClr val="414141"/>
                 </a:solidFill>
@@ -6422,7 +6422,7 @@
           <a:noFill/>
         </p:spPr>
         <p:txBody>
-          <a:bodyPr wrap="square">
+          <a:bodyPr wrap="square" lIns="0" rIns="0" tIns="0" bIns="0">
             <a:spAutoFit/>
           </a:bodyPr>
           <a:lstStyle/>
@@ -6458,13 +6458,13 @@
           <a:noFill/>
         </p:spPr>
         <p:txBody>
-          <a:bodyPr wrap="square">
-            <a:spAutoFit/>
-          </a:bodyPr>
-          <a:lstStyle/>
-          <a:p>
-            <a:pPr>
-              <a:defRPr sz="1400" b="0">
+          <a:bodyPr wrap="square" lIns="0" rIns="0" tIns="0" bIns="0">
+            <a:spAutoFit/>
+          </a:bodyPr>
+          <a:lstStyle/>
+          <a:p>
+            <a:pPr>
+              <a:defRPr sz="1300" b="0">
                 <a:solidFill>
                   <a:srgbClr val="414141"/>
                 </a:solidFill>
@@ -6499,7 +6499,7 @@
           <a:noFill/>
         </p:spPr>
         <p:txBody>
-          <a:bodyPr wrap="square">
+          <a:bodyPr wrap="square" lIns="0" rIns="0" tIns="0" bIns="0">
             <a:spAutoFit/>
           </a:bodyPr>
           <a:lstStyle/>
@@ -6553,7 +6553,7 @@
           <a:noFill/>
         </p:spPr>
         <p:txBody>
-          <a:bodyPr wrap="square">
+          <a:bodyPr wrap="square" lIns="0" rIns="0" tIns="0" bIns="0">
             <a:spAutoFit/>
           </a:bodyPr>
           <a:lstStyle/>
@@ -6589,7 +6589,7 @@
           <a:noFill/>
         </p:spPr>
         <p:txBody>
-          <a:bodyPr wrap="square">
+          <a:bodyPr wrap="square" lIns="0" rIns="0" tIns="0" bIns="0">
             <a:spAutoFit/>
           </a:bodyPr>
           <a:lstStyle/>
@@ -6625,7 +6625,7 @@
           <a:noFill/>
         </p:spPr>
         <p:txBody>
-          <a:bodyPr wrap="square">
+          <a:bodyPr wrap="square" lIns="0" rIns="0" tIns="0" bIns="0">
             <a:spAutoFit/>
           </a:bodyPr>
           <a:lstStyle/>
@@ -6661,7 +6661,7 @@
           <a:noFill/>
         </p:spPr>
         <p:txBody>
-          <a:bodyPr wrap="square">
+          <a:bodyPr wrap="square" lIns="0" rIns="0" tIns="0" bIns="0">
             <a:spAutoFit/>
           </a:bodyPr>
           <a:lstStyle/>
@@ -6697,7 +6697,7 @@
           <a:noFill/>
         </p:spPr>
         <p:txBody>
-          <a:bodyPr wrap="square">
+          <a:bodyPr wrap="square" lIns="0" rIns="0" tIns="0" bIns="0">
             <a:spAutoFit/>
           </a:bodyPr>
           <a:lstStyle/>
@@ -6733,7 +6733,7 @@
           <a:noFill/>
         </p:spPr>
         <p:txBody>
-          <a:bodyPr wrap="square">
+          <a:bodyPr wrap="square" lIns="0" rIns="0" tIns="0" bIns="0">
             <a:spAutoFit/>
           </a:bodyPr>
           <a:lstStyle/>
@@ -6769,7 +6769,7 @@
           <a:noFill/>
         </p:spPr>
         <p:txBody>
-          <a:bodyPr wrap="square">
+          <a:bodyPr wrap="square" lIns="0" rIns="0" tIns="0" bIns="0">
             <a:spAutoFit/>
           </a:bodyPr>
           <a:lstStyle/>
@@ -6823,7 +6823,7 @@
           <a:noFill/>
         </p:spPr>
         <p:txBody>
-          <a:bodyPr wrap="square">
+          <a:bodyPr wrap="square" lIns="0" rIns="0" tIns="0" bIns="0">
             <a:spAutoFit/>
           </a:bodyPr>
           <a:lstStyle/>
@@ -6859,7 +6859,7 @@
           <a:noFill/>
         </p:spPr>
         <p:txBody>
-          <a:bodyPr wrap="square">
+          <a:bodyPr wrap="square" lIns="0" rIns="0" tIns="0" bIns="0">
             <a:spAutoFit/>
           </a:bodyPr>
           <a:lstStyle/>
@@ -6895,7 +6895,7 @@
           <a:noFill/>
         </p:spPr>
         <p:txBody>
-          <a:bodyPr wrap="square">
+          <a:bodyPr wrap="square" lIns="0" rIns="0" tIns="0" bIns="0">
             <a:spAutoFit/>
           </a:bodyPr>
           <a:lstStyle/>
@@ -6931,7 +6931,7 @@
           <a:noFill/>
         </p:spPr>
         <p:txBody>
-          <a:bodyPr wrap="square">
+          <a:bodyPr wrap="square" lIns="0" rIns="0" tIns="0" bIns="0">
             <a:spAutoFit/>
           </a:bodyPr>
           <a:lstStyle/>
@@ -6967,7 +6967,7 @@
           <a:noFill/>
         </p:spPr>
         <p:txBody>
-          <a:bodyPr wrap="square">
+          <a:bodyPr wrap="square" lIns="0" rIns="0" tIns="0" bIns="0">
             <a:spAutoFit/>
           </a:bodyPr>
           <a:lstStyle/>
@@ -7003,7 +7003,7 @@
           <a:noFill/>
         </p:spPr>
         <p:txBody>
-          <a:bodyPr wrap="square">
+          <a:bodyPr wrap="square" lIns="0" rIns="0" tIns="0" bIns="0">
             <a:spAutoFit/>
           </a:bodyPr>
           <a:lstStyle/>
@@ -7039,7 +7039,7 @@
           <a:noFill/>
         </p:spPr>
         <p:txBody>
-          <a:bodyPr wrap="square">
+          <a:bodyPr wrap="square" lIns="0" rIns="0" tIns="0" bIns="0">
             <a:spAutoFit/>
           </a:bodyPr>
           <a:lstStyle/>
@@ -7083,7 +7083,7 @@
           <a:noFill/>
         </p:spPr>
         <p:txBody>
-          <a:bodyPr wrap="square">
+          <a:bodyPr wrap="square" lIns="0" rIns="0" tIns="0" bIns="0">
             <a:spAutoFit/>
           </a:bodyPr>
           <a:lstStyle/>

</xml_diff>

<commit_message>
Fix Ansible slide text alignment
Co-authored-by: Copilot <223556219+Copilot@users.noreply.github.com>
</commit_message>
<xml_diff>
--- a/docs/csv-user-manager-presentation.pptx
+++ b/docs/csv-user-manager-presentation.pptx
@@ -3311,7 +3311,7 @@
         <p:spPr>
           <a:xfrm>
             <a:off x="822960" y="1371600"/>
-            <a:ext cx="10332720" cy="566928"/>
+            <a:ext cx="10332720" cy="694944"/>
           </a:xfrm>
           <a:prstGeom prst="rect">
             <a:avLst/>
@@ -3346,8 +3346,8 @@
         </p:nvSpPr>
         <p:spPr>
           <a:xfrm>
-            <a:off x="822960" y="2057400"/>
-            <a:ext cx="10332720" cy="566928"/>
+            <a:off x="822960" y="2121408"/>
+            <a:ext cx="10332720" cy="694944"/>
           </a:xfrm>
           <a:prstGeom prst="rect">
             <a:avLst/>
@@ -3382,8 +3382,8 @@
         </p:nvSpPr>
         <p:spPr>
           <a:xfrm>
-            <a:off x="822960" y="2743200"/>
-            <a:ext cx="10332720" cy="566928"/>
+            <a:off x="822960" y="2871215"/>
+            <a:ext cx="10332720" cy="694944"/>
           </a:xfrm>
           <a:prstGeom prst="rect">
             <a:avLst/>
@@ -3418,8 +3418,8 @@
         </p:nvSpPr>
         <p:spPr>
           <a:xfrm>
-            <a:off x="822960" y="3429000"/>
-            <a:ext cx="10332720" cy="566928"/>
+            <a:off x="822960" y="3621024"/>
+            <a:ext cx="10332720" cy="694944"/>
           </a:xfrm>
           <a:prstGeom prst="rect">
             <a:avLst/>
@@ -3454,8 +3454,8 @@
         </p:nvSpPr>
         <p:spPr>
           <a:xfrm>
-            <a:off x="822960" y="4114800"/>
-            <a:ext cx="10332720" cy="566928"/>
+            <a:off x="822960" y="4370831"/>
+            <a:ext cx="10332720" cy="694944"/>
           </a:xfrm>
           <a:prstGeom prst="rect">
             <a:avLst/>
@@ -6490,8 +6490,8 @@
         </p:nvSpPr>
         <p:spPr>
           <a:xfrm>
-            <a:off x="777240" y="5257800"/>
-            <a:ext cx="10698480" cy="594360"/>
+            <a:off x="777240" y="5230368"/>
+            <a:ext cx="10698480" cy="658368"/>
           </a:xfrm>
           <a:prstGeom prst="rect">
             <a:avLst/>
@@ -6513,7 +6513,11 @@
               </a:defRPr>
             </a:pPr>
             <a:r>
-              <a:t>Recommended commands: ansible-playbook -i inventory update-group-block.yml --check --diff  →  apply  →  update-user-block.yml  →  setup-local-user-homes.yml</a:t>
+              <a:t>Recommended order (run as user ansible):</a:t>
+            </a:r>
+            <a:br/>
+            <a:r>
+              <a:t>update-group-block.yml  -&gt;  update-user-block.yml  -&gt;  setup-local-user-homes.yml</a:t>
             </a:r>
           </a:p>
         </p:txBody>
@@ -6581,7 +6585,7 @@
         <p:spPr>
           <a:xfrm>
             <a:off x="822960" y="1371600"/>
-            <a:ext cx="10332720" cy="566928"/>
+            <a:ext cx="10332720" cy="694944"/>
           </a:xfrm>
           <a:prstGeom prst="rect">
             <a:avLst/>
@@ -6616,8 +6620,8 @@
         </p:nvSpPr>
         <p:spPr>
           <a:xfrm>
-            <a:off x="822960" y="2057400"/>
-            <a:ext cx="10332720" cy="566928"/>
+            <a:off x="822960" y="2121408"/>
+            <a:ext cx="10332720" cy="694944"/>
           </a:xfrm>
           <a:prstGeom prst="rect">
             <a:avLst/>
@@ -6652,8 +6656,8 @@
         </p:nvSpPr>
         <p:spPr>
           <a:xfrm>
-            <a:off x="822960" y="2743200"/>
-            <a:ext cx="10332720" cy="566928"/>
+            <a:off x="822960" y="2871215"/>
+            <a:ext cx="10332720" cy="694944"/>
           </a:xfrm>
           <a:prstGeom prst="rect">
             <a:avLst/>
@@ -6688,8 +6692,8 @@
         </p:nvSpPr>
         <p:spPr>
           <a:xfrm>
-            <a:off x="822960" y="3429000"/>
-            <a:ext cx="10332720" cy="566928"/>
+            <a:off x="822960" y="3621024"/>
+            <a:ext cx="10332720" cy="694944"/>
           </a:xfrm>
           <a:prstGeom prst="rect">
             <a:avLst/>
@@ -6724,8 +6728,8 @@
         </p:nvSpPr>
         <p:spPr>
           <a:xfrm>
-            <a:off x="822960" y="4114800"/>
-            <a:ext cx="10332720" cy="566928"/>
+            <a:off x="822960" y="4370831"/>
+            <a:ext cx="10332720" cy="694944"/>
           </a:xfrm>
           <a:prstGeom prst="rect">
             <a:avLst/>
@@ -6760,8 +6764,8 @@
         </p:nvSpPr>
         <p:spPr>
           <a:xfrm>
-            <a:off x="822960" y="4800600"/>
-            <a:ext cx="10332720" cy="566928"/>
+            <a:off x="822960" y="5120640"/>
+            <a:ext cx="10332720" cy="694944"/>
           </a:xfrm>
           <a:prstGeom prst="rect">
             <a:avLst/>

</xml_diff>

<commit_message>
Fix local homes card overlap
Co-authored-by: Copilot <223556219+Copilot@users.noreply.github.com>
</commit_message>
<xml_diff>
--- a/docs/csv-user-manager-presentation.pptx
+++ b/docs/csv-user-manager-presentation.pptx
@@ -6436,7 +6436,7 @@
               </a:defRPr>
             </a:pPr>
             <a:r>
-              <a:t>3. setup-local-user-homes.yml</a:t>
+              <a:t>3. Local homes and keys</a:t>
             </a:r>
           </a:p>
         </p:txBody>
@@ -6471,6 +6471,11 @@
                 <a:latin typeface="Aptos"/>
               </a:defRPr>
             </a:pPr>
+            <a:r>
+              <a:t>Playbook: `setup-local-user-homes.yml`</a:t>
+            </a:r>
+            <a:br/>
+            <a:br/>
             <a:r>
               <a:t>Target: `localhost` only</a:t>
             </a:r>

</xml_diff>

<commit_message>
Document one-time SSH group setup
Co-authored-by: Copilot <223556219+Copilot@users.noreply.github.com>
</commit_message>
<xml_diff>
--- a/docs/csv-user-manager-presentation.pptx
+++ b/docs/csv-user-manager-presentation.pptx
@@ -6111,7 +6111,7 @@
               </a:defRPr>
             </a:pPr>
             <a:r>
-              <a:t>Run as user `ansible` from the controller; preview with `--check --diff` first.</a:t>
+              <a:t>Run as user `ansible` from the controller; preview with `--check --diff` first. Allow SSH group setup runs once.</a:t>
             </a:r>
           </a:p>
         </p:txBody>
@@ -6510,7 +6510,7 @@
           <a:lstStyle/>
           <a:p>
             <a:pPr>
-              <a:defRPr sz="1500" b="1">
+              <a:defRPr sz="1400" b="1">
                 <a:solidFill>
                   <a:srgbClr val="212529"/>
                 </a:solidFill>
@@ -6518,11 +6518,7 @@
               </a:defRPr>
             </a:pPr>
             <a:r>
-              <a:t>Recommended order (run as user ansible):</a:t>
-            </a:r>
-            <a:br/>
-            <a:r>
-              <a:t>update-group-block.yml  -&gt;  update-user-block.yml  -&gt;  setup-local-user-homes.yml</a:t>
+              <a:t>Initial setup: update-group-block.yml  -&gt;  update-user-block.yml  -&gt;  sshd_allow_group.yml (once)  -&gt;  setup-local-user-homes.yml</a:t>
             </a:r>
           </a:p>
         </p:txBody>

</xml_diff>

<commit_message>
clean up images and presentation
</commit_message>
<xml_diff>
--- a/docs/csv-user-manager-presentation.pptx
+++ b/docs/csv-user-manager-presentation.pptx
@@ -14,6 +14,7 @@
     <p:sldId id="262" r:id="rId13"/>
     <p:sldId id="263" r:id="rId14"/>
     <p:sldId id="264" r:id="rId15"/>
+    <p:sldId id="265" r:id="rId16"/>
   </p:sldIdLst>
   <p:sldSz cx="12191695" cy="6858000" type="screen4x3"/>
   <p:notesSz cx="6858000" cy="9144000"/>
@@ -3220,6 +3221,320 @@
 </p:sld>
 </file>
 
+<file path=ppt/slides/slide10.xml><?xml version="1.0" encoding="utf-8"?>
+<p:sld xmlns:a="http://schemas.openxmlformats.org/drawingml/2006/main" xmlns:p="http://schemas.openxmlformats.org/presentationml/2006/main" xmlns:r="http://schemas.openxmlformats.org/officeDocument/2006/relationships">
+  <p:cSld>
+    <p:spTree>
+      <p:nvGrpSpPr>
+        <p:cNvPr id="1" name=""/>
+        <p:cNvGrpSpPr/>
+        <p:nvPr/>
+      </p:nvGrpSpPr>
+      <p:grpSpPr/>
+      <p:sp>
+        <p:nvSpPr>
+          <p:cNvPr id="2" name="TextBox 1"/>
+          <p:cNvSpPr txBox="1"/>
+          <p:nvPr/>
+        </p:nvSpPr>
+        <p:spPr>
+          <a:xfrm>
+            <a:off x="548640" y="320040"/>
+            <a:ext cx="11064240" cy="502920"/>
+          </a:xfrm>
+          <a:prstGeom prst="rect">
+            <a:avLst/>
+          </a:prstGeom>
+          <a:noFill/>
+        </p:spPr>
+        <p:txBody>
+          <a:bodyPr wrap="square" lIns="0" rIns="0" tIns="0" bIns="0">
+            <a:spAutoFit/>
+          </a:bodyPr>
+          <a:lstStyle/>
+          <a:p>
+            <a:pPr>
+              <a:defRPr sz="2800" b="1">
+                <a:solidFill>
+                  <a:srgbClr val="212529"/>
+                </a:solidFill>
+                <a:latin typeface="Aptos"/>
+              </a:defRPr>
+            </a:pPr>
+            <a:r>
+              <a:t>Quick start</a:t>
+            </a:r>
+          </a:p>
+        </p:txBody>
+      </p:sp>
+      <p:sp>
+        <p:nvSpPr>
+          <p:cNvPr id="3" name="TextBox 2"/>
+          <p:cNvSpPr txBox="1"/>
+          <p:nvPr/>
+        </p:nvSpPr>
+        <p:spPr>
+          <a:xfrm>
+            <a:off x="822960" y="1325880"/>
+            <a:ext cx="3200400" cy="320040"/>
+          </a:xfrm>
+          <a:prstGeom prst="rect">
+            <a:avLst/>
+          </a:prstGeom>
+          <a:noFill/>
+        </p:spPr>
+        <p:txBody>
+          <a:bodyPr wrap="square" lIns="0" rIns="0" tIns="0" bIns="0">
+            <a:spAutoFit/>
+          </a:bodyPr>
+          <a:lstStyle/>
+          <a:p>
+            <a:pPr>
+              <a:defRPr sz="2100" b="1">
+                <a:solidFill>
+                  <a:srgbClr val="4E73DF"/>
+                </a:solidFill>
+                <a:latin typeface="Aptos"/>
+              </a:defRPr>
+            </a:pPr>
+            <a:r>
+              <a:t>1. Start the dashboard</a:t>
+            </a:r>
+          </a:p>
+        </p:txBody>
+      </p:sp>
+      <p:sp>
+        <p:nvSpPr>
+          <p:cNvPr id="4" name="TextBox 3"/>
+          <p:cNvSpPr txBox="1"/>
+          <p:nvPr/>
+        </p:nvSpPr>
+        <p:spPr>
+          <a:xfrm>
+            <a:off x="822960" y="1737360"/>
+            <a:ext cx="4754880" cy="411480"/>
+          </a:xfrm>
+          <a:prstGeom prst="rect">
+            <a:avLst/>
+          </a:prstGeom>
+          <a:noFill/>
+        </p:spPr>
+        <p:txBody>
+          <a:bodyPr wrap="square" lIns="0" rIns="0" tIns="0" bIns="0">
+            <a:spAutoFit/>
+          </a:bodyPr>
+          <a:lstStyle/>
+          <a:p>
+            <a:pPr>
+              <a:defRPr sz="1900" b="1">
+                <a:solidFill>
+                  <a:srgbClr val="212529"/>
+                </a:solidFill>
+                <a:latin typeface="Aptos"/>
+              </a:defRPr>
+            </a:pPr>
+            <a:r>
+              <a:t>php -S 127.0.0.1:8000</a:t>
+            </a:r>
+          </a:p>
+        </p:txBody>
+      </p:sp>
+      <p:sp>
+        <p:nvSpPr>
+          <p:cNvPr id="5" name="TextBox 4"/>
+          <p:cNvSpPr txBox="1"/>
+          <p:nvPr/>
+        </p:nvSpPr>
+        <p:spPr>
+          <a:xfrm>
+            <a:off x="822960" y="2514600"/>
+            <a:ext cx="3200400" cy="320040"/>
+          </a:xfrm>
+          <a:prstGeom prst="rect">
+            <a:avLst/>
+          </a:prstGeom>
+          <a:noFill/>
+        </p:spPr>
+        <p:txBody>
+          <a:bodyPr wrap="square" lIns="0" rIns="0" tIns="0" bIns="0">
+            <a:spAutoFit/>
+          </a:bodyPr>
+          <a:lstStyle/>
+          <a:p>
+            <a:pPr>
+              <a:defRPr sz="2100" b="1">
+                <a:solidFill>
+                  <a:srgbClr val="2E59D9"/>
+                </a:solidFill>
+                <a:latin typeface="Aptos"/>
+              </a:defRPr>
+            </a:pPr>
+            <a:r>
+              <a:t>2. Edit and publish</a:t>
+            </a:r>
+          </a:p>
+        </p:txBody>
+      </p:sp>
+      <p:sp>
+        <p:nvSpPr>
+          <p:cNvPr id="6" name="TextBox 5"/>
+          <p:cNvSpPr txBox="1"/>
+          <p:nvPr/>
+        </p:nvSpPr>
+        <p:spPr>
+          <a:xfrm>
+            <a:off x="822960" y="2926080"/>
+            <a:ext cx="5303520" cy="411480"/>
+          </a:xfrm>
+          <a:prstGeom prst="rect">
+            <a:avLst/>
+          </a:prstGeom>
+          <a:noFill/>
+        </p:spPr>
+        <p:txBody>
+          <a:bodyPr wrap="square" lIns="0" rIns="0" tIns="0" bIns="0">
+            <a:spAutoFit/>
+          </a:bodyPr>
+          <a:lstStyle/>
+          <a:p>
+            <a:pPr>
+              <a:defRPr sz="1700" b="0">
+                <a:solidFill>
+                  <a:srgbClr val="373737"/>
+                </a:solidFill>
+                <a:latin typeface="Aptos"/>
+              </a:defRPr>
+            </a:pPr>
+            <a:r>
+              <a:t>Save users/hosts, then publish hosts-block.txt and users-block.txt.</a:t>
+            </a:r>
+          </a:p>
+        </p:txBody>
+      </p:sp>
+      <p:sp>
+        <p:nvSpPr>
+          <p:cNvPr id="7" name="TextBox 6"/>
+          <p:cNvSpPr txBox="1"/>
+          <p:nvPr/>
+        </p:nvSpPr>
+        <p:spPr>
+          <a:xfrm>
+            <a:off x="822960" y="3703320"/>
+            <a:ext cx="3200400" cy="320040"/>
+          </a:xfrm>
+          <a:prstGeom prst="rect">
+            <a:avLst/>
+          </a:prstGeom>
+          <a:noFill/>
+        </p:spPr>
+        <p:txBody>
+          <a:bodyPr wrap="square" lIns="0" rIns="0" tIns="0" bIns="0">
+            <a:spAutoFit/>
+          </a:bodyPr>
+          <a:lstStyle/>
+          <a:p>
+            <a:pPr>
+              <a:defRPr sz="2100" b="1">
+                <a:solidFill>
+                  <a:srgbClr val="4E73DF"/>
+                </a:solidFill>
+                <a:latin typeface="Aptos"/>
+              </a:defRPr>
+            </a:pPr>
+            <a:r>
+              <a:t>3. Apply in order</a:t>
+            </a:r>
+          </a:p>
+        </p:txBody>
+      </p:sp>
+      <p:sp>
+        <p:nvSpPr>
+          <p:cNvPr id="8" name="TextBox 7"/>
+          <p:cNvSpPr txBox="1"/>
+          <p:nvPr/>
+        </p:nvSpPr>
+        <p:spPr>
+          <a:xfrm>
+            <a:off x="822960" y="4114800"/>
+            <a:ext cx="5303520" cy="1097280"/>
+          </a:xfrm>
+          <a:prstGeom prst="rect">
+            <a:avLst/>
+          </a:prstGeom>
+          <a:noFill/>
+        </p:spPr>
+        <p:txBody>
+          <a:bodyPr wrap="square" lIns="0" rIns="0" tIns="0" bIns="0">
+            <a:spAutoFit/>
+          </a:bodyPr>
+          <a:lstStyle/>
+          <a:p>
+            <a:pPr>
+              <a:defRPr sz="1800" b="1">
+                <a:solidFill>
+                  <a:srgbClr val="212529"/>
+                </a:solidFill>
+                <a:latin typeface="Aptos"/>
+              </a:defRPr>
+            </a:pPr>
+            <a:r>
+              <a:t>update-group-block.yml</a:t>
+            </a:r>
+            <a:br/>
+            <a:r>
+              <a:t>update-user-block.yml</a:t>
+            </a:r>
+            <a:br/>
+            <a:r>
+              <a:t>setup-local-user-homes.yml</a:t>
+            </a:r>
+          </a:p>
+        </p:txBody>
+      </p:sp>
+      <p:sp>
+        <p:nvSpPr>
+          <p:cNvPr id="9" name="TextBox 8"/>
+          <p:cNvSpPr txBox="1"/>
+          <p:nvPr/>
+        </p:nvSpPr>
+        <p:spPr>
+          <a:xfrm>
+            <a:off x="6400800" y="1828800"/>
+            <a:ext cx="4754880" cy="1280160"/>
+          </a:xfrm>
+          <a:prstGeom prst="rect">
+            <a:avLst/>
+          </a:prstGeom>
+          <a:noFill/>
+        </p:spPr>
+        <p:txBody>
+          <a:bodyPr wrap="square" lIns="0" rIns="0" tIns="0" bIns="0">
+            <a:spAutoFit/>
+          </a:bodyPr>
+          <a:lstStyle/>
+          <a:p>
+            <a:pPr>
+              <a:defRPr sz="2400" b="1">
+                <a:solidFill>
+                  <a:srgbClr val="212529"/>
+                </a:solidFill>
+                <a:latin typeface="Aptos"/>
+              </a:defRPr>
+            </a:pPr>
+            <a:r>
+              <a:t>The dashboard provides the data and review surface; Ansible performs the controlled system changes.</a:t>
+            </a:r>
+          </a:p>
+        </p:txBody>
+      </p:sp>
+    </p:spTree>
+  </p:cSld>
+  <p:clrMapOvr>
+    <a:masterClrMapping/>
+  </p:clrMapOvr>
+</p:sld>
+</file>
+
 <file path=ppt/slides/slide2.xml><?xml version="1.0" encoding="utf-8"?>
 <p:sld xmlns:a="http://schemas.openxmlformats.org/drawingml/2006/main" xmlns:p="http://schemas.openxmlformats.org/presentationml/2006/main" xmlns:r="http://schemas.openxmlformats.org/officeDocument/2006/relationships">
   <p:cSld>
@@ -6075,7 +6390,7 @@
               </a:defRPr>
             </a:pPr>
             <a:r>
-              <a:t>Ansible playbooks and order</a:t>
+              <a:t>Target infrastructure</a:t>
             </a:r>
           </a:p>
         </p:txBody>
@@ -6111,53 +6426,44 @@
               </a:defRPr>
             </a:pPr>
             <a:r>
-              <a:t>Run as user `ansible` from the controller; preview with `--check --diff` first. Allow SSH group setup runs once.</a:t>
-            </a:r>
-          </a:p>
-        </p:txBody>
-      </p:sp>
-      <p:sp>
-        <p:nvSpPr>
-          <p:cNvPr id="4" name="Rounded Rectangle 3"/>
-          <p:cNvSpPr/>
-          <p:nvPr/>
-        </p:nvSpPr>
-        <p:spPr>
-          <a:xfrm>
-            <a:off x="640080" y="1234440"/>
-            <a:ext cx="3429000" cy="3474720"/>
-          </a:xfrm>
-          <a:prstGeom prst="roundRect">
-            <a:avLst/>
-          </a:prstGeom>
-          <a:solidFill>
-            <a:srgbClr val="FFFFFF"/>
-          </a:solidFill>
-          <a:ln w="19050">
-            <a:solidFill>
-              <a:srgbClr val="2E59D9"/>
-            </a:solidFill>
-          </a:ln>
-        </p:spPr>
-        <p:style>
-          <a:lnRef idx="1">
-            <a:schemeClr val="accent1"/>
-          </a:lnRef>
-          <a:fillRef idx="3">
-            <a:schemeClr val="accent1"/>
-          </a:fillRef>
-          <a:effectRef idx="2">
-            <a:schemeClr val="accent1"/>
-          </a:effectRef>
-          <a:fontRef idx="minor">
-            <a:schemeClr val="lt1"/>
-          </a:fontRef>
-        </p:style>
-        <p:txBody>
-          <a:bodyPr rtlCol="0" anchor="ctr"/>
-          <a:lstStyle/>
-          <a:p>
-            <a:pPr algn="ctr"/>
+              <a:t>The managed `virt` hosts run as KVM guests on the kvm1 hypervisor, served over NFS.</a:t>
+            </a:r>
+          </a:p>
+        </p:txBody>
+      </p:sp>
+      <p:sp>
+        <p:nvSpPr>
+          <p:cNvPr id="4" name="TextBox 3"/>
+          <p:cNvSpPr txBox="1"/>
+          <p:nvPr/>
+        </p:nvSpPr>
+        <p:spPr>
+          <a:xfrm>
+            <a:off x="502920" y="1371600"/>
+            <a:ext cx="3657600" cy="694944"/>
+          </a:xfrm>
+          <a:prstGeom prst="rect">
+            <a:avLst/>
+          </a:prstGeom>
+          <a:noFill/>
+        </p:spPr>
+        <p:txBody>
+          <a:bodyPr wrap="square" lIns="0" rIns="0" tIns="0" bIns="0">
+            <a:spAutoFit/>
+          </a:bodyPr>
+          <a:lstStyle/>
+          <a:p>
+            <a:pPr>
+              <a:defRPr sz="1300" b="0">
+                <a:solidFill>
+                  <a:srgbClr val="373737"/>
+                </a:solidFill>
+                <a:latin typeface="Aptos"/>
+              </a:defRPr>
+            </a:pPr>
+            <a:r>
+              <a:t>• Bare-metal kvm1 = Dell PowerEdge R660 - 64 CPU, 499 GiB RAM.</a:t>
+            </a:r>
           </a:p>
         </p:txBody>
       </p:sp>
@@ -6169,30 +6475,30 @@
         </p:nvSpPr>
         <p:spPr>
           <a:xfrm>
-            <a:off x="804671" y="1371600"/>
-            <a:ext cx="3108960" cy="320040"/>
-          </a:xfrm>
-          <a:prstGeom prst="rect">
-            <a:avLst/>
-          </a:prstGeom>
-          <a:noFill/>
-        </p:spPr>
-        <p:txBody>
-          <a:bodyPr wrap="square" lIns="0" rIns="0" tIns="0" bIns="0">
-            <a:spAutoFit/>
-          </a:bodyPr>
-          <a:lstStyle/>
-          <a:p>
-            <a:pPr>
-              <a:defRPr sz="1800" b="1">
-                <a:solidFill>
-                  <a:srgbClr val="2E59D9"/>
-                </a:solidFill>
-                <a:latin typeface="Aptos"/>
-              </a:defRPr>
-            </a:pPr>
-            <a:r>
-              <a:t>1. update-group-block.yml</a:t>
+            <a:off x="502920" y="1938528"/>
+            <a:ext cx="3657600" cy="694944"/>
+          </a:xfrm>
+          <a:prstGeom prst="rect">
+            <a:avLst/>
+          </a:prstGeom>
+          <a:noFill/>
+        </p:spPr>
+        <p:txBody>
+          <a:bodyPr wrap="square" lIns="0" rIns="0" tIns="0" bIns="0">
+            <a:spAutoFit/>
+          </a:bodyPr>
+          <a:lstStyle/>
+          <a:p>
+            <a:pPr>
+              <a:defRPr sz="1300" b="0">
+                <a:solidFill>
+                  <a:srgbClr val="373737"/>
+                </a:solidFill>
+                <a:latin typeface="Aptos"/>
+              </a:defRPr>
+            </a:pPr>
+            <a:r>
+              <a:t>• Four KVM guests: sv-quantum-lx25 - lx28 via libvirt.</a:t>
             </a:r>
           </a:p>
         </p:txBody>
@@ -6205,8 +6511,8 @@
         </p:nvSpPr>
         <p:spPr>
           <a:xfrm>
-            <a:off x="804671" y="1801368"/>
-            <a:ext cx="3108960" cy="2788920"/>
+            <a:off x="502920" y="2505456"/>
+            <a:ext cx="3657600" cy="694944"/>
           </a:xfrm>
           <a:prstGeom prst="rect">
             <a:avLst/>
@@ -6222,64 +6528,50 @@
             <a:pPr>
               <a:defRPr sz="1300" b="0">
                 <a:solidFill>
-                  <a:srgbClr val="414141"/>
-                </a:solidFill>
-                <a:latin typeface="Aptos"/>
-              </a:defRPr>
-            </a:pPr>
-            <a:r>
-              <a:t>Target: remote `virt` hosts</a:t>
-            </a:r>
-            <a:br/>
-            <a:br/>
-            <a:r>
-              <a:t>Reads `hosts-block.txt` and updates the managed section of `/etc/group` with backups and privilege escalation.</a:t>
-            </a:r>
-          </a:p>
-        </p:txBody>
-      </p:sp>
-      <p:sp>
-        <p:nvSpPr>
-          <p:cNvPr id="7" name="Rounded Rectangle 6"/>
-          <p:cNvSpPr/>
-          <p:nvPr/>
-        </p:nvSpPr>
-        <p:spPr>
-          <a:xfrm>
-            <a:off x="4389120" y="1234440"/>
-            <a:ext cx="3429000" cy="3474720"/>
-          </a:xfrm>
-          <a:prstGeom prst="roundRect">
-            <a:avLst/>
-          </a:prstGeom>
-          <a:solidFill>
-            <a:srgbClr val="FFFFFF"/>
-          </a:solidFill>
-          <a:ln w="19050">
-            <a:solidFill>
-              <a:srgbClr val="4E73DF"/>
-            </a:solidFill>
-          </a:ln>
-        </p:spPr>
-        <p:style>
-          <a:lnRef idx="1">
-            <a:schemeClr val="accent1"/>
-          </a:lnRef>
-          <a:fillRef idx="3">
-            <a:schemeClr val="accent1"/>
-          </a:fillRef>
-          <a:effectRef idx="2">
-            <a:schemeClr val="accent1"/>
-          </a:effectRef>
-          <a:fontRef idx="minor">
-            <a:schemeClr val="lt1"/>
-          </a:fontRef>
-        </p:style>
-        <p:txBody>
-          <a:bodyPr rtlCol="0" anchor="ctr"/>
-          <a:lstStyle/>
-          <a:p>
-            <a:pPr algn="ctr"/>
+                  <a:srgbClr val="373737"/>
+                </a:solidFill>
+                <a:latin typeface="Aptos"/>
+              </a:defRPr>
+            </a:pPr>
+            <a:r>
+              <a:t>• 8 x SAS HDD behind PERC H755 -&gt; RAID1 (OS) + RAID5 (data).</a:t>
+            </a:r>
+          </a:p>
+        </p:txBody>
+      </p:sp>
+      <p:sp>
+        <p:nvSpPr>
+          <p:cNvPr id="7" name="TextBox 6"/>
+          <p:cNvSpPr txBox="1"/>
+          <p:nvPr/>
+        </p:nvSpPr>
+        <p:spPr>
+          <a:xfrm>
+            <a:off x="502920" y="3072384"/>
+            <a:ext cx="3657600" cy="694944"/>
+          </a:xfrm>
+          <a:prstGeom prst="rect">
+            <a:avLst/>
+          </a:prstGeom>
+          <a:noFill/>
+        </p:spPr>
+        <p:txBody>
+          <a:bodyPr wrap="square" lIns="0" rIns="0" tIns="0" bIns="0">
+            <a:spAutoFit/>
+          </a:bodyPr>
+          <a:lstStyle/>
+          <a:p>
+            <a:pPr>
+              <a:defRPr sz="1300" b="0">
+                <a:solidFill>
+                  <a:srgbClr val="373737"/>
+                </a:solidFill>
+                <a:latin typeface="Aptos"/>
+              </a:defRPr>
+            </a:pPr>
+            <a:r>
+              <a:t>• ubuntu-vg: guest OS + /share/opt; vg_pool: guest disks + /usr/share/home.</a:t>
+            </a:r>
           </a:p>
         </p:txBody>
       </p:sp>
@@ -6291,44 +6583,8 @@
         </p:nvSpPr>
         <p:spPr>
           <a:xfrm>
-            <a:off x="4553712" y="1371600"/>
-            <a:ext cx="3108960" cy="320040"/>
-          </a:xfrm>
-          <a:prstGeom prst="rect">
-            <a:avLst/>
-          </a:prstGeom>
-          <a:noFill/>
-        </p:spPr>
-        <p:txBody>
-          <a:bodyPr wrap="square" lIns="0" rIns="0" tIns="0" bIns="0">
-            <a:spAutoFit/>
-          </a:bodyPr>
-          <a:lstStyle/>
-          <a:p>
-            <a:pPr>
-              <a:defRPr sz="1800" b="1">
-                <a:solidFill>
-                  <a:srgbClr val="4E73DF"/>
-                </a:solidFill>
-                <a:latin typeface="Aptos"/>
-              </a:defRPr>
-            </a:pPr>
-            <a:r>
-              <a:t>2. update-user-block.yml</a:t>
-            </a:r>
-          </a:p>
-        </p:txBody>
-      </p:sp>
-      <p:sp>
-        <p:nvSpPr>
-          <p:cNvPr id="9" name="TextBox 8"/>
-          <p:cNvSpPr txBox="1"/>
-          <p:nvPr/>
-        </p:nvSpPr>
-        <p:spPr>
-          <a:xfrm>
-            <a:off x="4553712" y="1801368"/>
-            <a:ext cx="3108960" cy="2788920"/>
+            <a:off x="502920" y="3639312"/>
+            <a:ext cx="3657600" cy="694944"/>
           </a:xfrm>
           <a:prstGeom prst="rect">
             <a:avLst/>
@@ -6344,185 +6600,41 @@
             <a:pPr>
               <a:defRPr sz="1300" b="0">
                 <a:solidFill>
-                  <a:srgbClr val="414141"/>
-                </a:solidFill>
-                <a:latin typeface="Aptos"/>
-              </a:defRPr>
-            </a:pPr>
-            <a:r>
-              <a:t>Target: remote `virt` hosts</a:t>
-            </a:r>
-            <a:br/>
-            <a:br/>
-            <a:r>
-              <a:t>Creates primary groups, updates the managed `/etc/passwd` section, and runs `pwconv`.</a:t>
-            </a:r>
-          </a:p>
-        </p:txBody>
-      </p:sp>
-      <p:sp>
-        <p:nvSpPr>
-          <p:cNvPr id="10" name="Rounded Rectangle 9"/>
-          <p:cNvSpPr/>
-          <p:nvPr/>
-        </p:nvSpPr>
-        <p:spPr>
-          <a:xfrm>
-            <a:off x="8138160" y="1234440"/>
-            <a:ext cx="3429000" cy="3474720"/>
-          </a:xfrm>
-          <a:prstGeom prst="roundRect">
-            <a:avLst/>
-          </a:prstGeom>
-          <a:solidFill>
-            <a:srgbClr val="FFFFFF"/>
-          </a:solidFill>
-          <a:ln w="19050">
-            <a:solidFill>
-              <a:srgbClr val="2E59D9"/>
-            </a:solidFill>
-          </a:ln>
-        </p:spPr>
-        <p:style>
-          <a:lnRef idx="1">
-            <a:schemeClr val="accent1"/>
-          </a:lnRef>
-          <a:fillRef idx="3">
-            <a:schemeClr val="accent1"/>
-          </a:fillRef>
-          <a:effectRef idx="2">
-            <a:schemeClr val="accent1"/>
-          </a:effectRef>
-          <a:fontRef idx="minor">
-            <a:schemeClr val="lt1"/>
-          </a:fontRef>
-        </p:style>
-        <p:txBody>
-          <a:bodyPr rtlCol="0" anchor="ctr"/>
-          <a:lstStyle/>
-          <a:p>
-            <a:pPr algn="ctr"/>
-          </a:p>
-        </p:txBody>
-      </p:sp>
-      <p:sp>
-        <p:nvSpPr>
-          <p:cNvPr id="11" name="TextBox 10"/>
-          <p:cNvSpPr txBox="1"/>
-          <p:nvPr/>
-        </p:nvSpPr>
-        <p:spPr>
-          <a:xfrm>
-            <a:off x="8302752" y="1371600"/>
-            <a:ext cx="3108960" cy="320040"/>
-          </a:xfrm>
-          <a:prstGeom prst="rect">
-            <a:avLst/>
-          </a:prstGeom>
-          <a:noFill/>
-        </p:spPr>
-        <p:txBody>
-          <a:bodyPr wrap="square" lIns="0" rIns="0" tIns="0" bIns="0">
-            <a:spAutoFit/>
-          </a:bodyPr>
-          <a:lstStyle/>
-          <a:p>
-            <a:pPr>
-              <a:defRPr sz="1800" b="1">
-                <a:solidFill>
-                  <a:srgbClr val="2E59D9"/>
-                </a:solidFill>
-                <a:latin typeface="Aptos"/>
-              </a:defRPr>
-            </a:pPr>
-            <a:r>
-              <a:t>3. Local homes and keys</a:t>
-            </a:r>
-          </a:p>
-        </p:txBody>
-      </p:sp>
-      <p:sp>
-        <p:nvSpPr>
-          <p:cNvPr id="12" name="TextBox 11"/>
-          <p:cNvSpPr txBox="1"/>
-          <p:nvPr/>
-        </p:nvSpPr>
-        <p:spPr>
-          <a:xfrm>
-            <a:off x="8302752" y="1801368"/>
-            <a:ext cx="3108960" cy="2788920"/>
-          </a:xfrm>
-          <a:prstGeom prst="rect">
-            <a:avLst/>
-          </a:prstGeom>
-          <a:noFill/>
-        </p:spPr>
-        <p:txBody>
-          <a:bodyPr wrap="square" lIns="0" rIns="0" tIns="0" bIns="0">
-            <a:spAutoFit/>
-          </a:bodyPr>
-          <a:lstStyle/>
-          <a:p>
-            <a:pPr>
-              <a:defRPr sz="1300" b="0">
-                <a:solidFill>
-                  <a:srgbClr val="414141"/>
-                </a:solidFill>
-                <a:latin typeface="Aptos"/>
-              </a:defRPr>
-            </a:pPr>
-            <a:r>
-              <a:t>Playbook: `setup-local-user-homes.yml`</a:t>
-            </a:r>
-            <a:br/>
-            <a:br/>
-            <a:r>
-              <a:t>Target: `localhost` only</a:t>
-            </a:r>
-            <a:br/>
-            <a:br/>
-            <a:r>
-              <a:t>Creates `/share/home` directories and `.ssh/authorized_keys` with correct ownership and permissions.</a:t>
-            </a:r>
-          </a:p>
-        </p:txBody>
-      </p:sp>
-      <p:sp>
-        <p:nvSpPr>
-          <p:cNvPr id="13" name="TextBox 12"/>
-          <p:cNvSpPr txBox="1"/>
-          <p:nvPr/>
-        </p:nvSpPr>
-        <p:spPr>
-          <a:xfrm>
-            <a:off x="777240" y="5230368"/>
-            <a:ext cx="10698480" cy="658368"/>
-          </a:xfrm>
-          <a:prstGeom prst="rect">
-            <a:avLst/>
-          </a:prstGeom>
-          <a:noFill/>
-        </p:spPr>
-        <p:txBody>
-          <a:bodyPr wrap="square" lIns="0" rIns="0" tIns="0" bIns="0">
-            <a:spAutoFit/>
-          </a:bodyPr>
-          <a:lstStyle/>
-          <a:p>
-            <a:pPr>
-              <a:defRPr sz="1400" b="1">
-                <a:solidFill>
-                  <a:srgbClr val="212529"/>
-                </a:solidFill>
-                <a:latin typeface="Aptos"/>
-              </a:defRPr>
-            </a:pPr>
-            <a:r>
-              <a:t>Initial setup: update-group-block.yml  -&gt;  update-user-block.yml  -&gt;  sshd_allow_group.yml (once)  -&gt;  setup-local-user-homes.yml</a:t>
-            </a:r>
-          </a:p>
-        </p:txBody>
-      </p:sp>
+                  <a:srgbClr val="373737"/>
+                </a:solidFill>
+                <a:latin typeface="Aptos"/>
+              </a:defRPr>
+            </a:pPr>
+            <a:r>
+              <a:t>• Guests mount NFSv4.2 exports and use bridging on br0.</a:t>
+            </a:r>
+          </a:p>
+        </p:txBody>
+      </p:sp>
+      <p:pic>
+        <p:nvPicPr>
+          <p:cNvPr id="9" name="Picture 8" descr="kvm1-system.png"/>
+          <p:cNvPicPr>
+            <a:picLocks noChangeAspect="1"/>
+          </p:cNvPicPr>
+          <p:nvPr/>
+        </p:nvPicPr>
+        <p:blipFill>
+          <a:blip r:embed="rId2"/>
+          <a:stretch>
+            <a:fillRect/>
+          </a:stretch>
+        </p:blipFill>
+        <p:spPr>
+          <a:xfrm>
+            <a:off x="4306824" y="1234440"/>
+            <a:ext cx="7562088" cy="5577040"/>
+          </a:xfrm>
+          <a:prstGeom prst="rect">
+            <a:avLst/>
+          </a:prstGeom>
+        </p:spPr>
+      </p:pic>
     </p:spTree>
   </p:cSld>
   <p:clrMapOvr>
@@ -6572,7 +6684,7 @@
               </a:defRPr>
             </a:pPr>
             <a:r>
-              <a:t>Advantages and operating principles</a:t>
+              <a:t>Ansible playbooks and order</a:t>
             </a:r>
           </a:p>
         </p:txBody>
@@ -6585,67 +6697,76 @@
         </p:nvSpPr>
         <p:spPr>
           <a:xfrm>
-            <a:off x="822960" y="1371600"/>
-            <a:ext cx="10332720" cy="694944"/>
-          </a:xfrm>
-          <a:prstGeom prst="rect">
-            <a:avLst/>
-          </a:prstGeom>
-          <a:noFill/>
-        </p:spPr>
-        <p:txBody>
-          <a:bodyPr wrap="square" lIns="0" rIns="0" tIns="0" bIns="0">
-            <a:spAutoFit/>
-          </a:bodyPr>
-          <a:lstStyle/>
-          <a:p>
-            <a:pPr>
-              <a:defRPr sz="2100" b="0">
-                <a:solidFill>
-                  <a:srgbClr val="373737"/>
-                </a:solidFill>
-                <a:latin typeface="Aptos"/>
-              </a:defRPr>
-            </a:pPr>
-            <a:r>
-              <a:t>• Simple deployment model: PHP, CSV, generated blocks, and playbooks can live in `/var/www/html`.</a:t>
-            </a:r>
-          </a:p>
-        </p:txBody>
-      </p:sp>
-      <p:sp>
-        <p:nvSpPr>
-          <p:cNvPr id="4" name="TextBox 3"/>
-          <p:cNvSpPr txBox="1"/>
-          <p:nvPr/>
-        </p:nvSpPr>
-        <p:spPr>
-          <a:xfrm>
-            <a:off x="822960" y="2121408"/>
-            <a:ext cx="10332720" cy="694944"/>
-          </a:xfrm>
-          <a:prstGeom prst="rect">
-            <a:avLst/>
-          </a:prstGeom>
-          <a:noFill/>
-        </p:spPr>
-        <p:txBody>
-          <a:bodyPr wrap="square" lIns="0" rIns="0" tIns="0" bIns="0">
-            <a:spAutoFit/>
-          </a:bodyPr>
-          <a:lstStyle/>
-          <a:p>
-            <a:pPr>
-              <a:defRPr sz="2100" b="0">
-                <a:solidFill>
-                  <a:srgbClr val="373737"/>
-                </a:solidFill>
-                <a:latin typeface="Aptos"/>
-              </a:defRPr>
-            </a:pPr>
-            <a:r>
-              <a:t>• Human-readable inputs support review, backup, and straightforward recovery.</a:t>
-            </a:r>
+            <a:off x="566928" y="868680"/>
+            <a:ext cx="10972800" cy="320040"/>
+          </a:xfrm>
+          <a:prstGeom prst="rect">
+            <a:avLst/>
+          </a:prstGeom>
+          <a:noFill/>
+        </p:spPr>
+        <p:txBody>
+          <a:bodyPr wrap="square" lIns="0" rIns="0" tIns="0" bIns="0">
+            <a:spAutoFit/>
+          </a:bodyPr>
+          <a:lstStyle/>
+          <a:p>
+            <a:pPr>
+              <a:defRPr sz="1300" b="0">
+                <a:solidFill>
+                  <a:srgbClr val="6C757D"/>
+                </a:solidFill>
+                <a:latin typeface="Aptos"/>
+              </a:defRPr>
+            </a:pPr>
+            <a:r>
+              <a:t>Run as user `ansible` from the controller; preview with `--check --diff` first. Allow SSH group setup runs once.</a:t>
+            </a:r>
+          </a:p>
+        </p:txBody>
+      </p:sp>
+      <p:sp>
+        <p:nvSpPr>
+          <p:cNvPr id="4" name="Rounded Rectangle 3"/>
+          <p:cNvSpPr/>
+          <p:nvPr/>
+        </p:nvSpPr>
+        <p:spPr>
+          <a:xfrm>
+            <a:off x="640080" y="1234440"/>
+            <a:ext cx="3429000" cy="3474720"/>
+          </a:xfrm>
+          <a:prstGeom prst="roundRect">
+            <a:avLst/>
+          </a:prstGeom>
+          <a:solidFill>
+            <a:srgbClr val="FFFFFF"/>
+          </a:solidFill>
+          <a:ln w="19050">
+            <a:solidFill>
+              <a:srgbClr val="2E59D9"/>
+            </a:solidFill>
+          </a:ln>
+        </p:spPr>
+        <p:style>
+          <a:lnRef idx="1">
+            <a:schemeClr val="accent1"/>
+          </a:lnRef>
+          <a:fillRef idx="3">
+            <a:schemeClr val="accent1"/>
+          </a:fillRef>
+          <a:effectRef idx="2">
+            <a:schemeClr val="accent1"/>
+          </a:effectRef>
+          <a:fontRef idx="minor">
+            <a:schemeClr val="lt1"/>
+          </a:fontRef>
+        </p:style>
+        <p:txBody>
+          <a:bodyPr rtlCol="0" anchor="ctr"/>
+          <a:lstStyle/>
+          <a:p>
+            <a:pPr algn="ctr"/>
           </a:p>
         </p:txBody>
       </p:sp>
@@ -6657,30 +6778,30 @@
         </p:nvSpPr>
         <p:spPr>
           <a:xfrm>
-            <a:off x="822960" y="2871215"/>
-            <a:ext cx="10332720" cy="694944"/>
-          </a:xfrm>
-          <a:prstGeom prst="rect">
-            <a:avLst/>
-          </a:prstGeom>
-          <a:noFill/>
-        </p:spPr>
-        <p:txBody>
-          <a:bodyPr wrap="square" lIns="0" rIns="0" tIns="0" bIns="0">
-            <a:spAutoFit/>
-          </a:bodyPr>
-          <a:lstStyle/>
-          <a:p>
-            <a:pPr>
-              <a:defRPr sz="2100" b="0">
-                <a:solidFill>
-                  <a:srgbClr val="373737"/>
-                </a:solidFill>
-                <a:latin typeface="Aptos"/>
-              </a:defRPr>
-            </a:pPr>
-            <a:r>
-              <a:t>• Manual Ansible execution keeps production changes intentional and observable.</a:t>
+            <a:off x="804671" y="1371600"/>
+            <a:ext cx="3108960" cy="320040"/>
+          </a:xfrm>
+          <a:prstGeom prst="rect">
+            <a:avLst/>
+          </a:prstGeom>
+          <a:noFill/>
+        </p:spPr>
+        <p:txBody>
+          <a:bodyPr wrap="square" lIns="0" rIns="0" tIns="0" bIns="0">
+            <a:spAutoFit/>
+          </a:bodyPr>
+          <a:lstStyle/>
+          <a:p>
+            <a:pPr>
+              <a:defRPr sz="1800" b="1">
+                <a:solidFill>
+                  <a:srgbClr val="2E59D9"/>
+                </a:solidFill>
+                <a:latin typeface="Aptos"/>
+              </a:defRPr>
+            </a:pPr>
+            <a:r>
+              <a:t>1. update-group-block.yml</a:t>
             </a:r>
           </a:p>
         </p:txBody>
@@ -6693,67 +6814,81 @@
         </p:nvSpPr>
         <p:spPr>
           <a:xfrm>
-            <a:off x="822960" y="3621024"/>
-            <a:ext cx="10332720" cy="694944"/>
-          </a:xfrm>
-          <a:prstGeom prst="rect">
-            <a:avLst/>
-          </a:prstGeom>
-          <a:noFill/>
-        </p:spPr>
-        <p:txBody>
-          <a:bodyPr wrap="square" lIns="0" rIns="0" tIns="0" bIns="0">
-            <a:spAutoFit/>
-          </a:bodyPr>
-          <a:lstStyle/>
-          <a:p>
-            <a:pPr>
-              <a:defRPr sz="2100" b="0">
-                <a:solidFill>
-                  <a:srgbClr val="373737"/>
-                </a:solidFill>
-                <a:latin typeface="Aptos"/>
-              </a:defRPr>
-            </a:pPr>
-            <a:r>
-              <a:t>• Targeted host synchronization preserves unrelated members instead of rebuilding lists.</a:t>
-            </a:r>
-          </a:p>
-        </p:txBody>
-      </p:sp>
-      <p:sp>
-        <p:nvSpPr>
-          <p:cNvPr id="7" name="TextBox 6"/>
-          <p:cNvSpPr txBox="1"/>
-          <p:nvPr/>
-        </p:nvSpPr>
-        <p:spPr>
-          <a:xfrm>
-            <a:off x="822960" y="4370831"/>
-            <a:ext cx="10332720" cy="694944"/>
-          </a:xfrm>
-          <a:prstGeom prst="rect">
-            <a:avLst/>
-          </a:prstGeom>
-          <a:noFill/>
-        </p:spPr>
-        <p:txBody>
-          <a:bodyPr wrap="square" lIns="0" rIns="0" tIns="0" bIns="0">
-            <a:spAutoFit/>
-          </a:bodyPr>
-          <a:lstStyle/>
-          <a:p>
-            <a:pPr>
-              <a:defRPr sz="2100" b="0">
-                <a:solidFill>
-                  <a:srgbClr val="373737"/>
-                </a:solidFill>
-                <a:latin typeface="Aptos"/>
-              </a:defRPr>
-            </a:pPr>
-            <a:r>
-              <a:t>• Generated files use standard `/etc/passwd` and `/etc/group` formats.</a:t>
-            </a:r>
+            <a:off x="804671" y="1801368"/>
+            <a:ext cx="3108960" cy="2788920"/>
+          </a:xfrm>
+          <a:prstGeom prst="rect">
+            <a:avLst/>
+          </a:prstGeom>
+          <a:noFill/>
+        </p:spPr>
+        <p:txBody>
+          <a:bodyPr wrap="square" lIns="0" rIns="0" tIns="0" bIns="0">
+            <a:spAutoFit/>
+          </a:bodyPr>
+          <a:lstStyle/>
+          <a:p>
+            <a:pPr>
+              <a:defRPr sz="1300" b="0">
+                <a:solidFill>
+                  <a:srgbClr val="414141"/>
+                </a:solidFill>
+                <a:latin typeface="Aptos"/>
+              </a:defRPr>
+            </a:pPr>
+            <a:r>
+              <a:t>Target: remote `virt` hosts</a:t>
+            </a:r>
+            <a:br/>
+            <a:br/>
+            <a:r>
+              <a:t>Reads `hosts-block.txt` and updates the managed section of `/etc/group` with backups and privilege escalation.</a:t>
+            </a:r>
+          </a:p>
+        </p:txBody>
+      </p:sp>
+      <p:sp>
+        <p:nvSpPr>
+          <p:cNvPr id="7" name="Rounded Rectangle 6"/>
+          <p:cNvSpPr/>
+          <p:nvPr/>
+        </p:nvSpPr>
+        <p:spPr>
+          <a:xfrm>
+            <a:off x="4389120" y="1234440"/>
+            <a:ext cx="3429000" cy="3474720"/>
+          </a:xfrm>
+          <a:prstGeom prst="roundRect">
+            <a:avLst/>
+          </a:prstGeom>
+          <a:solidFill>
+            <a:srgbClr val="FFFFFF"/>
+          </a:solidFill>
+          <a:ln w="19050">
+            <a:solidFill>
+              <a:srgbClr val="4E73DF"/>
+            </a:solidFill>
+          </a:ln>
+        </p:spPr>
+        <p:style>
+          <a:lnRef idx="1">
+            <a:schemeClr val="accent1"/>
+          </a:lnRef>
+          <a:fillRef idx="3">
+            <a:schemeClr val="accent1"/>
+          </a:fillRef>
+          <a:effectRef idx="2">
+            <a:schemeClr val="accent1"/>
+          </a:effectRef>
+          <a:fontRef idx="minor">
+            <a:schemeClr val="lt1"/>
+          </a:fontRef>
+        </p:style>
+        <p:txBody>
+          <a:bodyPr rtlCol="0" anchor="ctr"/>
+          <a:lstStyle/>
+          <a:p>
+            <a:pPr algn="ctr"/>
           </a:p>
         </p:txBody>
       </p:sp>
@@ -6765,30 +6900,234 @@
         </p:nvSpPr>
         <p:spPr>
           <a:xfrm>
-            <a:off x="822960" y="5120640"/>
-            <a:ext cx="10332720" cy="694944"/>
-          </a:xfrm>
-          <a:prstGeom prst="rect">
-            <a:avLst/>
-          </a:prstGeom>
-          <a:noFill/>
-        </p:spPr>
-        <p:txBody>
-          <a:bodyPr wrap="square" lIns="0" rIns="0" tIns="0" bIns="0">
-            <a:spAutoFit/>
-          </a:bodyPr>
-          <a:lstStyle/>
-          <a:p>
-            <a:pPr>
-              <a:defRPr sz="2100" b="0">
-                <a:solidFill>
-                  <a:srgbClr val="373737"/>
-                </a:solidFill>
-                <a:latin typeface="Aptos"/>
-              </a:defRPr>
-            </a:pPr>
-            <a:r>
-              <a:t>• Authentication and one-way password hashing protect dashboard access.</a:t>
+            <a:off x="4553712" y="1371600"/>
+            <a:ext cx="3108960" cy="320040"/>
+          </a:xfrm>
+          <a:prstGeom prst="rect">
+            <a:avLst/>
+          </a:prstGeom>
+          <a:noFill/>
+        </p:spPr>
+        <p:txBody>
+          <a:bodyPr wrap="square" lIns="0" rIns="0" tIns="0" bIns="0">
+            <a:spAutoFit/>
+          </a:bodyPr>
+          <a:lstStyle/>
+          <a:p>
+            <a:pPr>
+              <a:defRPr sz="1800" b="1">
+                <a:solidFill>
+                  <a:srgbClr val="4E73DF"/>
+                </a:solidFill>
+                <a:latin typeface="Aptos"/>
+              </a:defRPr>
+            </a:pPr>
+            <a:r>
+              <a:t>2. update-user-block.yml</a:t>
+            </a:r>
+          </a:p>
+        </p:txBody>
+      </p:sp>
+      <p:sp>
+        <p:nvSpPr>
+          <p:cNvPr id="9" name="TextBox 8"/>
+          <p:cNvSpPr txBox="1"/>
+          <p:nvPr/>
+        </p:nvSpPr>
+        <p:spPr>
+          <a:xfrm>
+            <a:off x="4553712" y="1801368"/>
+            <a:ext cx="3108960" cy="2788920"/>
+          </a:xfrm>
+          <a:prstGeom prst="rect">
+            <a:avLst/>
+          </a:prstGeom>
+          <a:noFill/>
+        </p:spPr>
+        <p:txBody>
+          <a:bodyPr wrap="square" lIns="0" rIns="0" tIns="0" bIns="0">
+            <a:spAutoFit/>
+          </a:bodyPr>
+          <a:lstStyle/>
+          <a:p>
+            <a:pPr>
+              <a:defRPr sz="1300" b="0">
+                <a:solidFill>
+                  <a:srgbClr val="414141"/>
+                </a:solidFill>
+                <a:latin typeface="Aptos"/>
+              </a:defRPr>
+            </a:pPr>
+            <a:r>
+              <a:t>Target: remote `virt` hosts</a:t>
+            </a:r>
+            <a:br/>
+            <a:br/>
+            <a:r>
+              <a:t>Creates primary groups, updates the managed `/etc/passwd` section, and runs `pwconv`.</a:t>
+            </a:r>
+          </a:p>
+        </p:txBody>
+      </p:sp>
+      <p:sp>
+        <p:nvSpPr>
+          <p:cNvPr id="10" name="Rounded Rectangle 9"/>
+          <p:cNvSpPr/>
+          <p:nvPr/>
+        </p:nvSpPr>
+        <p:spPr>
+          <a:xfrm>
+            <a:off x="8138160" y="1234440"/>
+            <a:ext cx="3429000" cy="3474720"/>
+          </a:xfrm>
+          <a:prstGeom prst="roundRect">
+            <a:avLst/>
+          </a:prstGeom>
+          <a:solidFill>
+            <a:srgbClr val="FFFFFF"/>
+          </a:solidFill>
+          <a:ln w="19050">
+            <a:solidFill>
+              <a:srgbClr val="2E59D9"/>
+            </a:solidFill>
+          </a:ln>
+        </p:spPr>
+        <p:style>
+          <a:lnRef idx="1">
+            <a:schemeClr val="accent1"/>
+          </a:lnRef>
+          <a:fillRef idx="3">
+            <a:schemeClr val="accent1"/>
+          </a:fillRef>
+          <a:effectRef idx="2">
+            <a:schemeClr val="accent1"/>
+          </a:effectRef>
+          <a:fontRef idx="minor">
+            <a:schemeClr val="lt1"/>
+          </a:fontRef>
+        </p:style>
+        <p:txBody>
+          <a:bodyPr rtlCol="0" anchor="ctr"/>
+          <a:lstStyle/>
+          <a:p>
+            <a:pPr algn="ctr"/>
+          </a:p>
+        </p:txBody>
+      </p:sp>
+      <p:sp>
+        <p:nvSpPr>
+          <p:cNvPr id="11" name="TextBox 10"/>
+          <p:cNvSpPr txBox="1"/>
+          <p:nvPr/>
+        </p:nvSpPr>
+        <p:spPr>
+          <a:xfrm>
+            <a:off x="8302752" y="1371600"/>
+            <a:ext cx="3108960" cy="320040"/>
+          </a:xfrm>
+          <a:prstGeom prst="rect">
+            <a:avLst/>
+          </a:prstGeom>
+          <a:noFill/>
+        </p:spPr>
+        <p:txBody>
+          <a:bodyPr wrap="square" lIns="0" rIns="0" tIns="0" bIns="0">
+            <a:spAutoFit/>
+          </a:bodyPr>
+          <a:lstStyle/>
+          <a:p>
+            <a:pPr>
+              <a:defRPr sz="1800" b="1">
+                <a:solidFill>
+                  <a:srgbClr val="2E59D9"/>
+                </a:solidFill>
+                <a:latin typeface="Aptos"/>
+              </a:defRPr>
+            </a:pPr>
+            <a:r>
+              <a:t>3. Local homes and keys</a:t>
+            </a:r>
+          </a:p>
+        </p:txBody>
+      </p:sp>
+      <p:sp>
+        <p:nvSpPr>
+          <p:cNvPr id="12" name="TextBox 11"/>
+          <p:cNvSpPr txBox="1"/>
+          <p:nvPr/>
+        </p:nvSpPr>
+        <p:spPr>
+          <a:xfrm>
+            <a:off x="8302752" y="1801368"/>
+            <a:ext cx="3108960" cy="2788920"/>
+          </a:xfrm>
+          <a:prstGeom prst="rect">
+            <a:avLst/>
+          </a:prstGeom>
+          <a:noFill/>
+        </p:spPr>
+        <p:txBody>
+          <a:bodyPr wrap="square" lIns="0" rIns="0" tIns="0" bIns="0">
+            <a:spAutoFit/>
+          </a:bodyPr>
+          <a:lstStyle/>
+          <a:p>
+            <a:pPr>
+              <a:defRPr sz="1300" b="0">
+                <a:solidFill>
+                  <a:srgbClr val="414141"/>
+                </a:solidFill>
+                <a:latin typeface="Aptos"/>
+              </a:defRPr>
+            </a:pPr>
+            <a:r>
+              <a:t>Playbook: `setup-local-user-homes.yml`</a:t>
+            </a:r>
+            <a:br/>
+            <a:br/>
+            <a:r>
+              <a:t>Target: `localhost` only</a:t>
+            </a:r>
+            <a:br/>
+            <a:br/>
+            <a:r>
+              <a:t>Creates `/share/home` directories and `.ssh/authorized_keys` with correct ownership and permissions.</a:t>
+            </a:r>
+          </a:p>
+        </p:txBody>
+      </p:sp>
+      <p:sp>
+        <p:nvSpPr>
+          <p:cNvPr id="13" name="TextBox 12"/>
+          <p:cNvSpPr txBox="1"/>
+          <p:nvPr/>
+        </p:nvSpPr>
+        <p:spPr>
+          <a:xfrm>
+            <a:off x="777240" y="5230368"/>
+            <a:ext cx="10698480" cy="658368"/>
+          </a:xfrm>
+          <a:prstGeom prst="rect">
+            <a:avLst/>
+          </a:prstGeom>
+          <a:noFill/>
+        </p:spPr>
+        <p:txBody>
+          <a:bodyPr wrap="square" lIns="0" rIns="0" tIns="0" bIns="0">
+            <a:spAutoFit/>
+          </a:bodyPr>
+          <a:lstStyle/>
+          <a:p>
+            <a:pPr>
+              <a:defRPr sz="1400" b="1">
+                <a:solidFill>
+                  <a:srgbClr val="212529"/>
+                </a:solidFill>
+                <a:latin typeface="Aptos"/>
+              </a:defRPr>
+            </a:pPr>
+            <a:r>
+              <a:t>Initial setup: update-group-block.yml  -&gt;  update-user-block.yml  -&gt;  sshd_allow_group.yml (once)  -&gt;  setup-local-user-homes.yml</a:t>
             </a:r>
           </a:p>
         </p:txBody>
@@ -6842,7 +7181,7 @@
               </a:defRPr>
             </a:pPr>
             <a:r>
-              <a:t>Quick start</a:t>
+              <a:t>Advantages and operating principles</a:t>
             </a:r>
           </a:p>
         </p:txBody>
@@ -6855,30 +7194,30 @@
         </p:nvSpPr>
         <p:spPr>
           <a:xfrm>
-            <a:off x="822960" y="1325880"/>
-            <a:ext cx="3200400" cy="320040"/>
-          </a:xfrm>
-          <a:prstGeom prst="rect">
-            <a:avLst/>
-          </a:prstGeom>
-          <a:noFill/>
-        </p:spPr>
-        <p:txBody>
-          <a:bodyPr wrap="square" lIns="0" rIns="0" tIns="0" bIns="0">
-            <a:spAutoFit/>
-          </a:bodyPr>
-          <a:lstStyle/>
-          <a:p>
-            <a:pPr>
-              <a:defRPr sz="2100" b="1">
-                <a:solidFill>
-                  <a:srgbClr val="4E73DF"/>
-                </a:solidFill>
-                <a:latin typeface="Aptos"/>
-              </a:defRPr>
-            </a:pPr>
-            <a:r>
-              <a:t>1. Start the dashboard</a:t>
+            <a:off x="822960" y="1371600"/>
+            <a:ext cx="10332720" cy="694944"/>
+          </a:xfrm>
+          <a:prstGeom prst="rect">
+            <a:avLst/>
+          </a:prstGeom>
+          <a:noFill/>
+        </p:spPr>
+        <p:txBody>
+          <a:bodyPr wrap="square" lIns="0" rIns="0" tIns="0" bIns="0">
+            <a:spAutoFit/>
+          </a:bodyPr>
+          <a:lstStyle/>
+          <a:p>
+            <a:pPr>
+              <a:defRPr sz="2100" b="0">
+                <a:solidFill>
+                  <a:srgbClr val="373737"/>
+                </a:solidFill>
+                <a:latin typeface="Aptos"/>
+              </a:defRPr>
+            </a:pPr>
+            <a:r>
+              <a:t>• Simple deployment model: PHP, CSV, generated blocks, and playbooks can live in `/var/www/html`.</a:t>
             </a:r>
           </a:p>
         </p:txBody>
@@ -6891,30 +7230,30 @@
         </p:nvSpPr>
         <p:spPr>
           <a:xfrm>
-            <a:off x="822960" y="1737360"/>
-            <a:ext cx="4754880" cy="411480"/>
-          </a:xfrm>
-          <a:prstGeom prst="rect">
-            <a:avLst/>
-          </a:prstGeom>
-          <a:noFill/>
-        </p:spPr>
-        <p:txBody>
-          <a:bodyPr wrap="square" lIns="0" rIns="0" tIns="0" bIns="0">
-            <a:spAutoFit/>
-          </a:bodyPr>
-          <a:lstStyle/>
-          <a:p>
-            <a:pPr>
-              <a:defRPr sz="1900" b="1">
-                <a:solidFill>
-                  <a:srgbClr val="212529"/>
-                </a:solidFill>
-                <a:latin typeface="Aptos"/>
-              </a:defRPr>
-            </a:pPr>
-            <a:r>
-              <a:t>php -S 127.0.0.1:8000</a:t>
+            <a:off x="822960" y="2121408"/>
+            <a:ext cx="10332720" cy="694944"/>
+          </a:xfrm>
+          <a:prstGeom prst="rect">
+            <a:avLst/>
+          </a:prstGeom>
+          <a:noFill/>
+        </p:spPr>
+        <p:txBody>
+          <a:bodyPr wrap="square" lIns="0" rIns="0" tIns="0" bIns="0">
+            <a:spAutoFit/>
+          </a:bodyPr>
+          <a:lstStyle/>
+          <a:p>
+            <a:pPr>
+              <a:defRPr sz="2100" b="0">
+                <a:solidFill>
+                  <a:srgbClr val="373737"/>
+                </a:solidFill>
+                <a:latin typeface="Aptos"/>
+              </a:defRPr>
+            </a:pPr>
+            <a:r>
+              <a:t>• Human-readable inputs support review, backup, and straightforward recovery.</a:t>
             </a:r>
           </a:p>
         </p:txBody>
@@ -6927,30 +7266,30 @@
         </p:nvSpPr>
         <p:spPr>
           <a:xfrm>
-            <a:off x="822960" y="2514600"/>
-            <a:ext cx="3200400" cy="320040"/>
-          </a:xfrm>
-          <a:prstGeom prst="rect">
-            <a:avLst/>
-          </a:prstGeom>
-          <a:noFill/>
-        </p:spPr>
-        <p:txBody>
-          <a:bodyPr wrap="square" lIns="0" rIns="0" tIns="0" bIns="0">
-            <a:spAutoFit/>
-          </a:bodyPr>
-          <a:lstStyle/>
-          <a:p>
-            <a:pPr>
-              <a:defRPr sz="2100" b="1">
-                <a:solidFill>
-                  <a:srgbClr val="2E59D9"/>
-                </a:solidFill>
-                <a:latin typeface="Aptos"/>
-              </a:defRPr>
-            </a:pPr>
-            <a:r>
-              <a:t>2. Edit and publish</a:t>
+            <a:off x="822960" y="2871215"/>
+            <a:ext cx="10332720" cy="694944"/>
+          </a:xfrm>
+          <a:prstGeom prst="rect">
+            <a:avLst/>
+          </a:prstGeom>
+          <a:noFill/>
+        </p:spPr>
+        <p:txBody>
+          <a:bodyPr wrap="square" lIns="0" rIns="0" tIns="0" bIns="0">
+            <a:spAutoFit/>
+          </a:bodyPr>
+          <a:lstStyle/>
+          <a:p>
+            <a:pPr>
+              <a:defRPr sz="2100" b="0">
+                <a:solidFill>
+                  <a:srgbClr val="373737"/>
+                </a:solidFill>
+                <a:latin typeface="Aptos"/>
+              </a:defRPr>
+            </a:pPr>
+            <a:r>
+              <a:t>• Manual Ansible execution keeps production changes intentional and observable.</a:t>
             </a:r>
           </a:p>
         </p:txBody>
@@ -6963,22 +7302,22 @@
         </p:nvSpPr>
         <p:spPr>
           <a:xfrm>
-            <a:off x="822960" y="2926080"/>
-            <a:ext cx="5303520" cy="411480"/>
-          </a:xfrm>
-          <a:prstGeom prst="rect">
-            <a:avLst/>
-          </a:prstGeom>
-          <a:noFill/>
-        </p:spPr>
-        <p:txBody>
-          <a:bodyPr wrap="square" lIns="0" rIns="0" tIns="0" bIns="0">
-            <a:spAutoFit/>
-          </a:bodyPr>
-          <a:lstStyle/>
-          <a:p>
-            <a:pPr>
-              <a:defRPr sz="1700" b="0">
+            <a:off x="822960" y="3621024"/>
+            <a:ext cx="10332720" cy="694944"/>
+          </a:xfrm>
+          <a:prstGeom prst="rect">
+            <a:avLst/>
+          </a:prstGeom>
+          <a:noFill/>
+        </p:spPr>
+        <p:txBody>
+          <a:bodyPr wrap="square" lIns="0" rIns="0" tIns="0" bIns="0">
+            <a:spAutoFit/>
+          </a:bodyPr>
+          <a:lstStyle/>
+          <a:p>
+            <a:pPr>
+              <a:defRPr sz="2100" b="0">
                 <a:solidFill>
                   <a:srgbClr val="373737"/>
                 </a:solidFill>
@@ -6986,7 +7325,7 @@
               </a:defRPr>
             </a:pPr>
             <a:r>
-              <a:t>Save users/hosts, then publish hosts-block.txt and users-block.txt.</a:t>
+              <a:t>• Targeted host synchronization preserves unrelated members instead of rebuilding lists.</a:t>
             </a:r>
           </a:p>
         </p:txBody>
@@ -6999,30 +7338,30 @@
         </p:nvSpPr>
         <p:spPr>
           <a:xfrm>
-            <a:off x="822960" y="3703320"/>
-            <a:ext cx="3200400" cy="320040"/>
-          </a:xfrm>
-          <a:prstGeom prst="rect">
-            <a:avLst/>
-          </a:prstGeom>
-          <a:noFill/>
-        </p:spPr>
-        <p:txBody>
-          <a:bodyPr wrap="square" lIns="0" rIns="0" tIns="0" bIns="0">
-            <a:spAutoFit/>
-          </a:bodyPr>
-          <a:lstStyle/>
-          <a:p>
-            <a:pPr>
-              <a:defRPr sz="2100" b="1">
-                <a:solidFill>
-                  <a:srgbClr val="4E73DF"/>
-                </a:solidFill>
-                <a:latin typeface="Aptos"/>
-              </a:defRPr>
-            </a:pPr>
-            <a:r>
-              <a:t>3. Apply in order</a:t>
+            <a:off x="822960" y="4370831"/>
+            <a:ext cx="10332720" cy="694944"/>
+          </a:xfrm>
+          <a:prstGeom prst="rect">
+            <a:avLst/>
+          </a:prstGeom>
+          <a:noFill/>
+        </p:spPr>
+        <p:txBody>
+          <a:bodyPr wrap="square" lIns="0" rIns="0" tIns="0" bIns="0">
+            <a:spAutoFit/>
+          </a:bodyPr>
+          <a:lstStyle/>
+          <a:p>
+            <a:pPr>
+              <a:defRPr sz="2100" b="0">
+                <a:solidFill>
+                  <a:srgbClr val="373737"/>
+                </a:solidFill>
+                <a:latin typeface="Aptos"/>
+              </a:defRPr>
+            </a:pPr>
+            <a:r>
+              <a:t>• Generated files use standard `/etc/passwd` and `/etc/group` formats.</a:t>
             </a:r>
           </a:p>
         </p:txBody>
@@ -7035,74 +7374,30 @@
         </p:nvSpPr>
         <p:spPr>
           <a:xfrm>
-            <a:off x="822960" y="4114800"/>
-            <a:ext cx="5303520" cy="1097280"/>
-          </a:xfrm>
-          <a:prstGeom prst="rect">
-            <a:avLst/>
-          </a:prstGeom>
-          <a:noFill/>
-        </p:spPr>
-        <p:txBody>
-          <a:bodyPr wrap="square" lIns="0" rIns="0" tIns="0" bIns="0">
-            <a:spAutoFit/>
-          </a:bodyPr>
-          <a:lstStyle/>
-          <a:p>
-            <a:pPr>
-              <a:defRPr sz="1800" b="1">
-                <a:solidFill>
-                  <a:srgbClr val="212529"/>
-                </a:solidFill>
-                <a:latin typeface="Aptos"/>
-              </a:defRPr>
-            </a:pPr>
-            <a:r>
-              <a:t>update-group-block.yml</a:t>
-            </a:r>
-            <a:br/>
-            <a:r>
-              <a:t>update-user-block.yml</a:t>
-            </a:r>
-            <a:br/>
-            <a:r>
-              <a:t>setup-local-user-homes.yml</a:t>
-            </a:r>
-          </a:p>
-        </p:txBody>
-      </p:sp>
-      <p:sp>
-        <p:nvSpPr>
-          <p:cNvPr id="9" name="TextBox 8"/>
-          <p:cNvSpPr txBox="1"/>
-          <p:nvPr/>
-        </p:nvSpPr>
-        <p:spPr>
-          <a:xfrm>
-            <a:off x="6400800" y="1828800"/>
-            <a:ext cx="4754880" cy="1280160"/>
-          </a:xfrm>
-          <a:prstGeom prst="rect">
-            <a:avLst/>
-          </a:prstGeom>
-          <a:noFill/>
-        </p:spPr>
-        <p:txBody>
-          <a:bodyPr wrap="square" lIns="0" rIns="0" tIns="0" bIns="0">
-            <a:spAutoFit/>
-          </a:bodyPr>
-          <a:lstStyle/>
-          <a:p>
-            <a:pPr>
-              <a:defRPr sz="2400" b="1">
-                <a:solidFill>
-                  <a:srgbClr val="212529"/>
-                </a:solidFill>
-                <a:latin typeface="Aptos"/>
-              </a:defRPr>
-            </a:pPr>
-            <a:r>
-              <a:t>The dashboard provides the data and review surface; Ansible performs the controlled system changes.</a:t>
+            <a:off x="822960" y="5120640"/>
+            <a:ext cx="10332720" cy="694944"/>
+          </a:xfrm>
+          <a:prstGeom prst="rect">
+            <a:avLst/>
+          </a:prstGeom>
+          <a:noFill/>
+        </p:spPr>
+        <p:txBody>
+          <a:bodyPr wrap="square" lIns="0" rIns="0" tIns="0" bIns="0">
+            <a:spAutoFit/>
+          </a:bodyPr>
+          <a:lstStyle/>
+          <a:p>
+            <a:pPr>
+              <a:defRPr sz="2100" b="0">
+                <a:solidFill>
+                  <a:srgbClr val="373737"/>
+                </a:solidFill>
+                <a:latin typeface="Aptos"/>
+              </a:defRPr>
+            </a:pPr>
+            <a:r>
+              <a:t>• Authentication and one-way password hashing protect dashboard access.</a:t>
             </a:r>
           </a:p>
         </p:txBody>

</xml_diff>